<commit_message>
NVIS-3201 Implement Trend Summary slide support
 - Update the intro slide so it can be used multiple times through a
 presentation
 - Add ability to have an index number in the top-right corner of the
 intro slide
 - Add a trend list slide that will take a list of content with title,
 summary and links
</commit_message>
<xml_diff>
--- a/samples/pptx/test-output.pptx
+++ b/samples/pptx/test-output.pptx
@@ -14,6 +14,10 @@
     <p:sldId id="261" r:id="rId6"/>
     <p:sldId id="262" r:id="rId7"/>
     <p:sldId id="263" r:id="rId8"/>
+    <p:sldId id="264" r:id="rId9"/>
+    <p:sldId id="265" r:id="rId10"/>
+    <p:sldId id="266" r:id="rId11"/>
+    <p:sldId id="267" r:id="rId12"/>
   </p:sldIdLst>
   <p:sldSz cx="9144000" cy="6858000" type="screen4x3"/>
   <p:notesSz cx="6858000" cy="9144000"/>
@@ -121,6 +125,122 @@
     </p:ext>
   </p:extLst>
 </p:presentation>
+</file>
+
+<file path=ppt/comments/modernComment_145_C73B0D4E.xml><?xml version="1.0" encoding="utf-8"?>
+<p188:cmLst xmlns:a="http://schemas.openxmlformats.org/drawingml/2006/main" xmlns:r="http://schemas.openxmlformats.org/officeDocument/2006/relationships" xmlns:p188="http://schemas.microsoft.com/office/powerpoint/2018/8/main">
+  <p188:cm id="{8E69C85A-BB49-47B8-94A9-DFEC57DBBD31}" authorId="{1BA2220E-EAF1-36E2-996E-E941808F1272}" created="2022-07-07T12:59:26.574">
+    <ac:deMkLst xmlns:ac="http://schemas.microsoft.com/office/drawing/2013/main/command">
+      <pc:docMk xmlns:pc="http://schemas.microsoft.com/office/powerpoint/2013/main/command"/>
+      <pc:sldMk xmlns:pc="http://schemas.microsoft.com/office/powerpoint/2013/main/command" cId="3342536014" sldId="325"/>
+      <ac:spMk id="40" creationId="{1F63B656-ED1F-A95B-D736-D0F4C45A8B98}"/>
+    </ac:deMkLst>
+    <p188:txBody>
+      <a:bodyPr/>
+      <a:lstStyle/>
+      <a:p>
+        <a:r>
+          <a:rPr lang="en-GB"/>
+          <a:t>cover image tbc</a:t>
+        </a:r>
+      </a:p>
+    </p188:txBody>
+  </p188:cm>
+  <p188:cm id="{A76B94FD-9AE5-4192-BFFB-D585490A37B9}" authorId="{1BA2220E-EAF1-36E2-996E-E941808F1272}" created="2022-07-07T13:21:23.898">
+    <pc:sldMkLst xmlns:pc="http://schemas.microsoft.com/office/powerpoint/2013/main/command">
+      <pc:docMk/>
+      <pc:sldMk cId="3342536014" sldId="325"/>
+    </pc:sldMkLst>
+    <p188:pos x="4486275" y="4025900"/>
+    <p188:txBody>
+      <a:bodyPr/>
+      <a:lstStyle/>
+      <a:p>
+        <a:r>
+          <a:rPr lang="en-GB"/>
+          <a:t>text taken from question, audience, market specified</a:t>
+        </a:r>
+      </a:p>
+    </p188:txBody>
+  </p188:cm>
+</p188:cmLst>
+</file>
+
+<file path=ppt/comments/modernComment_AD0_4A341540.xml><?xml version="1.0" encoding="utf-8"?>
+<p188:cmLst xmlns:a="http://schemas.openxmlformats.org/drawingml/2006/main" xmlns:r="http://schemas.openxmlformats.org/officeDocument/2006/relationships" xmlns:p188="http://schemas.microsoft.com/office/powerpoint/2018/8/main">
+  <p188:cm id="{7B67954C-DB90-4155-9FC1-96260E4EEBB1}" authorId="{1BA2220E-EAF1-36E2-996E-E941808F1272}" created="2022-07-07T13:41:19.759">
+    <pc:sldMkLst xmlns:pc="http://schemas.microsoft.com/office/powerpoint/2013/main/command">
+      <pc:docMk/>
+      <pc:sldMk cId="1244927296" sldId="2768"/>
+    </pc:sldMkLst>
+    <p188:txBody>
+      <a:bodyPr/>
+      <a:lstStyle/>
+      <a:p>
+        <a:r>
+          <a:rPr lang="en-GB"/>
+          <a:t>As above, to illustrate with more Trends</a:t>
+        </a:r>
+      </a:p>
+    </p188:txBody>
+  </p188:cm>
+</p188:cmLst>
+</file>
+
+<file path=ppt/comments/modernComment_AD1_23A2652.xml><?xml version="1.0" encoding="utf-8"?>
+<p188:cmLst xmlns:a="http://schemas.openxmlformats.org/drawingml/2006/main" xmlns:r="http://schemas.openxmlformats.org/officeDocument/2006/relationships" xmlns:p188="http://schemas.microsoft.com/office/powerpoint/2018/8/main">
+  <p188:cm id="{21016D25-BAB3-4C3B-8383-CCF2E2B02BF5}" authorId="{1BA2220E-EAF1-36E2-996E-E941808F1272}" created="2022-07-07T13:40:36.171">
+    <ac:deMkLst xmlns:ac="http://schemas.microsoft.com/office/drawing/2013/main/command">
+      <pc:docMk xmlns:pc="http://schemas.microsoft.com/office/powerpoint/2013/main/command"/>
+      <pc:sldMk xmlns:pc="http://schemas.microsoft.com/office/powerpoint/2013/main/command" cId="37365330" sldId="2769"/>
+      <ac:spMk id="5" creationId="{5A2A17F5-BDB6-3277-82F6-DE5BCCE429BF}"/>
+    </ac:deMkLst>
+    <p188:txBody>
+      <a:bodyPr/>
+      <a:lstStyle/>
+      <a:p>
+        <a:r>
+          <a:rPr lang="en-GB"/>
+          <a:t>additional slides can be introduced as needed, same styling, numbers continue to run as high as required</a:t>
+        </a:r>
+      </a:p>
+    </p188:txBody>
+  </p188:cm>
+  <p188:cm id="{B13BE74A-B089-4C78-901B-DCC50A7DF46E}" authorId="{1BA2220E-EAF1-36E2-996E-E941808F1272}" created="2022-07-07T13:40:54.374">
+    <ac:deMkLst xmlns:ac="http://schemas.microsoft.com/office/drawing/2013/main/command">
+      <pc:docMk xmlns:pc="http://schemas.microsoft.com/office/powerpoint/2013/main/command"/>
+      <pc:sldMk xmlns:pc="http://schemas.microsoft.com/office/powerpoint/2013/main/command" cId="37365330" sldId="2769"/>
+      <ac:spMk id="5" creationId="{5A2A17F5-BDB6-3277-82F6-DE5BCCE429BF}"/>
+    </ac:deMkLst>
+    <p188:txBody>
+      <a:bodyPr/>
+      <a:lstStyle/>
+      <a:p>
+        <a:r>
+          <a:rPr lang="en-GB"/>
+          <a:t>Numbers should not be bold, and should be in standard dark purple (not bright)</a:t>
+        </a:r>
+      </a:p>
+    </p188:txBody>
+  </p188:cm>
+  <p188:cm id="{CC0086BA-4831-482B-8056-C92A4B3C20CA}" authorId="{1BA2220E-EAF1-36E2-996E-E941808F1272}" created="2022-07-07T14:05:10.144">
+    <pc:sldMkLst xmlns:pc="http://schemas.microsoft.com/office/powerpoint/2013/main/command">
+      <pc:docMk/>
+      <pc:sldMk cId="37365330" sldId="2769"/>
+    </pc:sldMkLst>
+    <p188:pos x="463550" y="1374775"/>
+    <p188:txBody>
+      <a:bodyPr/>
+      <a:lstStyle/>
+      <a:p>
+        <a:r>
+          <a:rPr lang="en-GB"/>
+          <a:t> hyperlink to the trend page on main Collision site</a:t>
+        </a:r>
+      </a:p>
+    </p188:txBody>
+  </p188:cm>
+</p188:cmLst>
 </file>
 
 <file path=ppt/handoutMasters/handoutMaster1.xml><?xml version="1.0" encoding="utf-8"?>
@@ -9832,6 +9952,751 @@
 </p:sldLayout>
 </file>
 
+<file path=ppt/slideLayouts/slideLayout10.xml><?xml version="1.0" encoding="utf-8"?>
+<p:sldLayout xmlns:a="http://schemas.openxmlformats.org/drawingml/2006/main" xmlns:r="http://schemas.openxmlformats.org/officeDocument/2006/relationships" xmlns:p="http://schemas.openxmlformats.org/presentationml/2006/main" userDrawn="1">
+  <p:cSld name="scatterlist">
+    <p:spTree>
+      <p:nvGrpSpPr>
+        <p:cNvPr id="1" name=""/>
+        <p:cNvGrpSpPr/>
+        <p:nvPr/>
+      </p:nvGrpSpPr>
+      <p:grpSpPr>
+        <a:xfrm>
+          <a:off x="0" y="0"/>
+          <a:ext cx="0" cy="0"/>
+          <a:chOff x="0" y="0"/>
+          <a:chExt cx="0" cy="0"/>
+        </a:xfrm>
+      </p:grpSpPr>
+      <p:sp>
+        <p:nvSpPr>
+          <p:cNvPr id="8" name="TextBox 7"/>
+          <p:cNvSpPr txBox="1"/>
+          <p:nvPr/>
+        </p:nvSpPr>
+        <p:spPr>
+          <a:xfrm>
+            <a:off x="8662881" y="6524625"/>
+            <a:ext cx="309700" cy="194925"/>
+          </a:xfrm>
+          <a:prstGeom prst="rect">
+            <a:avLst/>
+          </a:prstGeom>
+          <a:noFill/>
+        </p:spPr>
+        <p:txBody>
+          <a:bodyPr wrap="none" rtlCol="0" anchor="ctr">
+            <a:spAutoFit/>
+          </a:bodyPr>
+          <a:lstStyle/>
+          <a:p>
+            <a:pPr algn="r">
+              <a:lnSpc>
+                <a:spcPts val="800"/>
+              </a:lnSpc>
+            </a:pPr>
+            <a:fld id="{0E0A9B4E-19F2-4E81-81C4-98D63547DE75}" type="slidenum">
+              <a:rPr lang="en-GB" sz="800" smtClean="0">
+                <a:solidFill>
+                  <a:schemeClr val="bg1">
+                    <a:lumMod val="65000"/>
+                  </a:schemeClr>
+                </a:solidFill>
+                <a:latin typeface="+mj-lt"/>
+                <a:cs typeface="Arial" pitchFamily="34" charset="0"/>
+              </a:rPr>
+              <a:pPr algn="r">
+                <a:lnSpc>
+                  <a:spcPts val="800"/>
+                </a:lnSpc>
+              </a:pPr>
+              <a:t>‹#›</a:t>
+            </a:fld>
+            <a:endParaRPr lang="en-GB" sz="800" dirty="0">
+              <a:solidFill>
+                <a:schemeClr val="bg1">
+                  <a:lumMod val="65000"/>
+                </a:schemeClr>
+              </a:solidFill>
+              <a:latin typeface="+mj-lt"/>
+              <a:cs typeface="Arial" pitchFamily="34" charset="0"/>
+            </a:endParaRPr>
+          </a:p>
+        </p:txBody>
+      </p:sp>
+      <p:sp>
+        <p:nvSpPr>
+          <p:cNvPr id="15" name="Text Placeholder 14"/>
+          <p:cNvSpPr>
+            <a:spLocks noGrp="1"/>
+          </p:cNvSpPr>
+          <p:nvPr>
+            <p:ph type="body" sz="quarter" idx="10" hasCustomPrompt="1"/>
+          </p:nvPr>
+        </p:nvSpPr>
+        <p:spPr>
+          <a:xfrm>
+            <a:off x="250825" y="6524625"/>
+            <a:ext cx="8363222" cy="194925"/>
+          </a:xfrm>
+          <a:prstGeom prst="rect">
+            <a:avLst/>
+          </a:prstGeom>
+        </p:spPr>
+        <p:txBody>
+          <a:bodyPr lIns="0" rIns="0" anchor="ctr">
+            <a:noAutofit/>
+          </a:bodyPr>
+          <a:lstStyle>
+            <a:lvl1pPr marL="0" marR="0" indent="0" algn="l" defTabSz="457200" rtl="0" eaLnBrk="1" fontAlgn="auto" latinLnBrk="0" hangingPunct="1">
+              <a:lnSpc>
+                <a:spcPts val="800"/>
+              </a:lnSpc>
+              <a:spcBef>
+                <a:spcPts val="0"/>
+              </a:spcBef>
+              <a:spcAft>
+                <a:spcPts val="0"/>
+              </a:spcAft>
+              <a:buClrTx/>
+              <a:buSzTx/>
+              <a:buFont typeface="Arial"/>
+              <a:buNone/>
+              <a:tabLst/>
+              <a:defRPr sz="800" baseline="0">
+                <a:solidFill>
+                  <a:schemeClr val="bg1">
+                    <a:lumMod val="65000"/>
+                  </a:schemeClr>
+                </a:solidFill>
+              </a:defRPr>
+            </a:lvl1pPr>
+          </a:lstStyle>
+          <a:p>
+            <a:pPr lvl="0"/>
+            <a:r>
+              <a:rPr lang="en-GB" dirty="0"/>
+              <a:t>Insert source/photo credit here</a:t>
+            </a:r>
+          </a:p>
+        </p:txBody>
+      </p:sp>
+      <p:cxnSp>
+        <p:nvCxnSpPr>
+          <p:cNvPr id="12" name="Straight Connector 11">
+            <a:extLst>
+              <a:ext uri="{FF2B5EF4-FFF2-40B4-BE49-F238E27FC236}">
+                <a16:creationId xmlns:a16="http://schemas.microsoft.com/office/drawing/2014/main" id="{A12E8C8F-1CF5-4C3D-9970-2DE6847A2B83}"/>
+              </a:ext>
+            </a:extLst>
+          </p:cNvPr>
+          <p:cNvCxnSpPr/>
+          <p:nvPr userDrawn="1"/>
+        </p:nvCxnSpPr>
+        <p:spPr>
+          <a:xfrm>
+            <a:off x="250825" y="620713"/>
+            <a:ext cx="8642350" cy="0"/>
+          </a:xfrm>
+          <a:prstGeom prst="line">
+            <a:avLst/>
+          </a:prstGeom>
+          <a:ln w="19050">
+            <a:solidFill>
+              <a:srgbClr val="29005A"/>
+            </a:solidFill>
+          </a:ln>
+          <a:effectLst/>
+        </p:spPr>
+        <p:style>
+          <a:lnRef idx="2">
+            <a:schemeClr val="accent1"/>
+          </a:lnRef>
+          <a:fillRef idx="0">
+            <a:schemeClr val="accent1"/>
+          </a:fillRef>
+          <a:effectRef idx="1">
+            <a:schemeClr val="accent1"/>
+          </a:effectRef>
+          <a:fontRef idx="minor">
+            <a:schemeClr val="tx1"/>
+          </a:fontRef>
+        </p:style>
+      </p:cxnSp>
+      <p:grpSp>
+        <p:nvGrpSpPr>
+          <p:cNvPr id="18" name="Group 4">
+            <a:extLst>
+              <a:ext uri="{FF2B5EF4-FFF2-40B4-BE49-F238E27FC236}">
+                <a16:creationId xmlns:a16="http://schemas.microsoft.com/office/drawing/2014/main" id="{984BF7BF-42D1-4505-BF3D-39C636A75D5F}"/>
+              </a:ext>
+            </a:extLst>
+          </p:cNvPr>
+          <p:cNvGrpSpPr>
+            <a:grpSpLocks noChangeAspect="1"/>
+          </p:cNvGrpSpPr>
+          <p:nvPr userDrawn="1"/>
+        </p:nvGrpSpPr>
+        <p:grpSpPr bwMode="auto">
+          <a:xfrm>
+            <a:off x="8530507" y="188914"/>
+            <a:ext cx="362668" cy="323850"/>
+            <a:chOff x="7024" y="3734"/>
+            <a:chExt cx="1308" cy="1168"/>
+          </a:xfrm>
+          <a:solidFill>
+            <a:schemeClr val="tx1"/>
+          </a:solidFill>
+        </p:grpSpPr>
+        <p:sp>
+          <p:nvSpPr>
+            <p:cNvPr id="19" name="Rectangle 5">
+              <a:extLst>
+                <a:ext uri="{FF2B5EF4-FFF2-40B4-BE49-F238E27FC236}">
+                  <a16:creationId xmlns:a16="http://schemas.microsoft.com/office/drawing/2014/main" id="{63D129A0-7861-48E3-82CE-4B31A9DE2AB7}"/>
+                </a:ext>
+              </a:extLst>
+            </p:cNvPr>
+            <p:cNvSpPr>
+              <a:spLocks noChangeArrowheads="1"/>
+            </p:cNvSpPr>
+            <p:nvPr/>
+          </p:nvSpPr>
+          <p:spPr bwMode="auto">
+            <a:xfrm>
+              <a:off x="7272" y="3734"/>
+              <a:ext cx="1060" cy="323"/>
+            </a:xfrm>
+            <a:prstGeom prst="rect">
+              <a:avLst/>
+            </a:prstGeom>
+            <a:grpFill/>
+            <a:ln>
+              <a:noFill/>
+            </a:ln>
+            <a:extLst>
+              <a:ext uri="{91240B29-F687-4F45-9708-019B960494DF}">
+                <a14:hiddenLine xmlns:a14="http://schemas.microsoft.com/office/drawing/2010/main" w="9525">
+                  <a:solidFill>
+                    <a:srgbClr val="000000"/>
+                  </a:solidFill>
+                  <a:miter lim="800000"/>
+                  <a:headEnd/>
+                  <a:tailEnd/>
+                </a14:hiddenLine>
+              </a:ext>
+            </a:extLst>
+          </p:spPr>
+          <p:txBody>
+            <a:bodyPr vert="horz" wrap="square" lIns="91440" tIns="45720" rIns="91440" bIns="45720" numCol="1" anchor="t" anchorCtr="0" compatLnSpc="1">
+              <a:prstTxWarp prst="textNoShape">
+                <a:avLst/>
+              </a:prstTxWarp>
+            </a:bodyPr>
+            <a:lstStyle/>
+            <a:p>
+              <a:endParaRPr lang="en-GB" sz="800"/>
+            </a:p>
+          </p:txBody>
+        </p:sp>
+        <p:sp>
+          <p:nvSpPr>
+            <p:cNvPr id="20" name="Rectangle 6">
+              <a:extLst>
+                <a:ext uri="{FF2B5EF4-FFF2-40B4-BE49-F238E27FC236}">
+                  <a16:creationId xmlns:a16="http://schemas.microsoft.com/office/drawing/2014/main" id="{95D98D7A-84A0-4408-B602-AA58D15FBF00}"/>
+                </a:ext>
+              </a:extLst>
+            </p:cNvPr>
+            <p:cNvSpPr>
+              <a:spLocks noChangeArrowheads="1"/>
+            </p:cNvSpPr>
+            <p:nvPr/>
+          </p:nvSpPr>
+          <p:spPr bwMode="auto">
+            <a:xfrm>
+              <a:off x="7272" y="4581"/>
+              <a:ext cx="417" cy="321"/>
+            </a:xfrm>
+            <a:prstGeom prst="rect">
+              <a:avLst/>
+            </a:prstGeom>
+            <a:grpFill/>
+            <a:ln>
+              <a:noFill/>
+            </a:ln>
+            <a:extLst>
+              <a:ext uri="{91240B29-F687-4F45-9708-019B960494DF}">
+                <a14:hiddenLine xmlns:a14="http://schemas.microsoft.com/office/drawing/2010/main" w="9525">
+                  <a:solidFill>
+                    <a:srgbClr val="000000"/>
+                  </a:solidFill>
+                  <a:miter lim="800000"/>
+                  <a:headEnd/>
+                  <a:tailEnd/>
+                </a14:hiddenLine>
+              </a:ext>
+            </a:extLst>
+          </p:spPr>
+          <p:txBody>
+            <a:bodyPr vert="horz" wrap="square" lIns="91440" tIns="45720" rIns="91440" bIns="45720" numCol="1" anchor="t" anchorCtr="0" compatLnSpc="1">
+              <a:prstTxWarp prst="textNoShape">
+                <a:avLst/>
+              </a:prstTxWarp>
+            </a:bodyPr>
+            <a:lstStyle/>
+            <a:p>
+              <a:endParaRPr lang="en-GB" sz="800"/>
+            </a:p>
+          </p:txBody>
+        </p:sp>
+        <p:sp>
+          <p:nvSpPr>
+            <p:cNvPr id="22" name="Rectangle 7">
+              <a:extLst>
+                <a:ext uri="{FF2B5EF4-FFF2-40B4-BE49-F238E27FC236}">
+                  <a16:creationId xmlns:a16="http://schemas.microsoft.com/office/drawing/2014/main" id="{2DAA5E84-01FA-42ED-A2EB-29D93423F95A}"/>
+                </a:ext>
+              </a:extLst>
+            </p:cNvPr>
+            <p:cNvSpPr>
+              <a:spLocks noChangeArrowheads="1"/>
+            </p:cNvSpPr>
+            <p:nvPr/>
+          </p:nvSpPr>
+          <p:spPr bwMode="auto">
+            <a:xfrm>
+              <a:off x="7024" y="4159"/>
+              <a:ext cx="989" cy="320"/>
+            </a:xfrm>
+            <a:prstGeom prst="rect">
+              <a:avLst/>
+            </a:prstGeom>
+            <a:grpFill/>
+            <a:ln>
+              <a:noFill/>
+            </a:ln>
+            <a:extLst>
+              <a:ext uri="{91240B29-F687-4F45-9708-019B960494DF}">
+                <a14:hiddenLine xmlns:a14="http://schemas.microsoft.com/office/drawing/2010/main" w="9525">
+                  <a:solidFill>
+                    <a:srgbClr val="000000"/>
+                  </a:solidFill>
+                  <a:miter lim="800000"/>
+                  <a:headEnd/>
+                  <a:tailEnd/>
+                </a14:hiddenLine>
+              </a:ext>
+            </a:extLst>
+          </p:spPr>
+          <p:txBody>
+            <a:bodyPr vert="horz" wrap="square" lIns="91440" tIns="45720" rIns="91440" bIns="45720" numCol="1" anchor="t" anchorCtr="0" compatLnSpc="1">
+              <a:prstTxWarp prst="textNoShape">
+                <a:avLst/>
+              </a:prstTxWarp>
+            </a:bodyPr>
+            <a:lstStyle/>
+            <a:p>
+              <a:endParaRPr lang="en-GB" sz="800"/>
+            </a:p>
+          </p:txBody>
+        </p:sp>
+      </p:grpSp>
+      <p:sp>
+        <p:nvSpPr>
+          <p:cNvPr id="6" name="Text Placeholder 5">
+            <a:extLst>
+              <a:ext uri="{FF2B5EF4-FFF2-40B4-BE49-F238E27FC236}">
+                <a16:creationId xmlns:a16="http://schemas.microsoft.com/office/drawing/2014/main" id="{F20DF6FC-68A1-4848-B68D-9C85C3B0BEE8}"/>
+              </a:ext>
+            </a:extLst>
+          </p:cNvPr>
+          <p:cNvSpPr>
+            <a:spLocks noGrp="1"/>
+          </p:cNvSpPr>
+          <p:nvPr>
+            <p:ph type="body" sz="quarter" idx="12"/>
+          </p:nvPr>
+        </p:nvSpPr>
+        <p:spPr>
+          <a:xfrm>
+            <a:off x="250825" y="331200"/>
+            <a:ext cx="8137525" cy="184666"/>
+          </a:xfrm>
+          <a:prstGeom prst="rect">
+            <a:avLst/>
+          </a:prstGeom>
+        </p:spPr>
+        <p:txBody>
+          <a:bodyPr wrap="square" lIns="0" tIns="0" rIns="0" bIns="0">
+            <a:spAutoFit/>
+          </a:bodyPr>
+          <a:lstStyle>
+            <a:lvl1pPr marL="0" indent="0">
+              <a:spcBef>
+                <a:spcPts val="0"/>
+              </a:spcBef>
+              <a:defRPr lang="en-US" sz="1200" b="0" kern="1200" smtClean="0">
+                <a:solidFill>
+                  <a:srgbClr val="29005A"/>
+                </a:solidFill>
+                <a:latin typeface="+mn-lt"/>
+                <a:ea typeface="+mn-ea"/>
+                <a:cs typeface="+mn-cs"/>
+              </a:defRPr>
+            </a:lvl1pPr>
+            <a:lvl2pPr>
+              <a:defRPr lang="en-US" sz="1200" b="1" kern="1200" dirty="0" smtClean="0">
+                <a:solidFill>
+                  <a:srgbClr val="29005A"/>
+                </a:solidFill>
+                <a:latin typeface="+mj-lt"/>
+                <a:ea typeface="+mn-ea"/>
+                <a:cs typeface="+mn-cs"/>
+              </a:defRPr>
+            </a:lvl2pPr>
+            <a:lvl3pPr>
+              <a:defRPr lang="en-US" sz="1200" b="1" kern="1200" dirty="0" smtClean="0">
+                <a:solidFill>
+                  <a:srgbClr val="29005A"/>
+                </a:solidFill>
+                <a:latin typeface="+mj-lt"/>
+                <a:ea typeface="+mn-ea"/>
+                <a:cs typeface="+mn-cs"/>
+              </a:defRPr>
+            </a:lvl3pPr>
+            <a:lvl4pPr>
+              <a:defRPr lang="en-US" sz="1200" b="1" kern="1200" dirty="0" smtClean="0">
+                <a:solidFill>
+                  <a:srgbClr val="29005A"/>
+                </a:solidFill>
+                <a:latin typeface="+mj-lt"/>
+                <a:ea typeface="+mn-ea"/>
+                <a:cs typeface="+mn-cs"/>
+              </a:defRPr>
+            </a:lvl4pPr>
+            <a:lvl5pPr>
+              <a:defRPr lang="en-GB" sz="1200" b="1" kern="1200" dirty="0">
+                <a:solidFill>
+                  <a:srgbClr val="29005A"/>
+                </a:solidFill>
+                <a:latin typeface="+mj-lt"/>
+                <a:ea typeface="+mn-ea"/>
+                <a:cs typeface="+mn-cs"/>
+              </a:defRPr>
+            </a:lvl5pPr>
+          </a:lstStyle>
+          <a:p>
+            <a:pPr lvl="0"/>
+            <a:r>
+              <a:rPr lang="en-US" dirty="0"/>
+              <a:t>Click to edit Master text styles</a:t>
+            </a:r>
+            <a:endParaRPr lang="en-GB" dirty="0"/>
+          </a:p>
+        </p:txBody>
+      </p:sp>
+      <p:sp>
+        <p:nvSpPr>
+          <p:cNvPr id="5" name="Text Placeholder 4">
+            <a:extLst>
+              <a:ext uri="{FF2B5EF4-FFF2-40B4-BE49-F238E27FC236}">
+                <a16:creationId xmlns:a16="http://schemas.microsoft.com/office/drawing/2014/main" id="{FEF99CFD-F91F-4578-8FFD-0A79BF068E09}"/>
+              </a:ext>
+            </a:extLst>
+          </p:cNvPr>
+          <p:cNvSpPr>
+            <a:spLocks noGrp="1"/>
+          </p:cNvSpPr>
+          <p:nvPr>
+            <p:ph type="body" sz="quarter" idx="13"/>
+          </p:nvPr>
+        </p:nvSpPr>
+        <p:spPr>
+          <a:xfrm>
+            <a:off x="250824" y="152636"/>
+            <a:ext cx="8137526" cy="184666"/>
+          </a:xfrm>
+          <a:prstGeom prst="rect">
+            <a:avLst/>
+          </a:prstGeom>
+        </p:spPr>
+        <p:txBody>
+          <a:bodyPr wrap="square" lIns="0" tIns="0" rIns="0" bIns="0">
+            <a:spAutoFit/>
+          </a:bodyPr>
+          <a:lstStyle>
+            <a:lvl1pPr marL="0" algn="l" defTabSz="914400" rtl="0" eaLnBrk="1" latinLnBrk="0" hangingPunct="1">
+              <a:defRPr lang="en-US" sz="1200" b="1" kern="1200" dirty="0" smtClean="0">
+                <a:solidFill>
+                  <a:srgbClr val="29005A"/>
+                </a:solidFill>
+                <a:latin typeface="+mj-lt"/>
+                <a:ea typeface="+mn-ea"/>
+                <a:cs typeface="+mn-cs"/>
+              </a:defRPr>
+            </a:lvl1pPr>
+            <a:lvl2pPr marL="0" algn="l" defTabSz="914400" rtl="0" eaLnBrk="1" latinLnBrk="0" hangingPunct="1">
+              <a:defRPr lang="en-US" sz="1200" b="1" kern="1200" dirty="0" smtClean="0">
+                <a:solidFill>
+                  <a:srgbClr val="29005A"/>
+                </a:solidFill>
+                <a:latin typeface="+mj-lt"/>
+                <a:ea typeface="+mn-ea"/>
+                <a:cs typeface="+mn-cs"/>
+              </a:defRPr>
+            </a:lvl2pPr>
+          </a:lstStyle>
+          <a:p>
+            <a:pPr marL="0" lvl="0" indent="0" algn="l" defTabSz="457200" rtl="0" eaLnBrk="1" latinLnBrk="0" hangingPunct="1">
+              <a:spcBef>
+                <a:spcPts val="0"/>
+              </a:spcBef>
+              <a:buFontTx/>
+              <a:buNone/>
+            </a:pPr>
+            <a:r>
+              <a:rPr lang="en-US" dirty="0"/>
+              <a:t>Click to edit Master text styles</a:t>
+            </a:r>
+            <a:endParaRPr lang="en-GB" dirty="0"/>
+          </a:p>
+        </p:txBody>
+      </p:sp>
+      <p:sp>
+        <p:nvSpPr>
+          <p:cNvPr id="17" name="Text Placeholder 11">
+            <a:extLst>
+              <a:ext uri="{FF2B5EF4-FFF2-40B4-BE49-F238E27FC236}">
+                <a16:creationId xmlns:a16="http://schemas.microsoft.com/office/drawing/2014/main" id="{D945A46C-648E-4FA0-B448-F9C692790C2D}"/>
+              </a:ext>
+            </a:extLst>
+          </p:cNvPr>
+          <p:cNvSpPr>
+            <a:spLocks noGrp="1"/>
+          </p:cNvSpPr>
+          <p:nvPr>
+            <p:ph type="body" sz="quarter" idx="11" hasCustomPrompt="1"/>
+          </p:nvPr>
+        </p:nvSpPr>
+        <p:spPr>
+          <a:xfrm>
+            <a:off x="259449" y="1374871"/>
+            <a:ext cx="2761200" cy="4986000"/>
+          </a:xfrm>
+          <a:prstGeom prst="rect">
+            <a:avLst/>
+          </a:prstGeom>
+        </p:spPr>
+        <p:txBody>
+          <a:bodyPr lIns="0" tIns="0" rIns="0" bIns="0"/>
+          <a:lstStyle>
+            <a:lvl1pPr marL="0" indent="0">
+              <a:lnSpc>
+                <a:spcPct val="90000"/>
+              </a:lnSpc>
+              <a:spcBef>
+                <a:spcPts val="0"/>
+              </a:spcBef>
+              <a:spcAft>
+                <a:spcPts val="1200"/>
+              </a:spcAft>
+              <a:defRPr sz="1400">
+                <a:solidFill>
+                  <a:schemeClr val="tx1"/>
+                </a:solidFill>
+                <a:latin typeface="+mn-lt"/>
+              </a:defRPr>
+            </a:lvl1pPr>
+          </a:lstStyle>
+          <a:p>
+            <a:pPr lvl="0"/>
+            <a:r>
+              <a:rPr lang="en-US" dirty="0"/>
+              <a:t>Insert text</a:t>
+            </a:r>
+            <a:endParaRPr lang="en-GB" dirty="0"/>
+          </a:p>
+        </p:txBody>
+      </p:sp>
+      <p:sp>
+        <p:nvSpPr>
+          <p:cNvPr id="14" name="Text Placeholder 11">
+            <a:extLst>
+              <a:ext uri="{FF2B5EF4-FFF2-40B4-BE49-F238E27FC236}">
+                <a16:creationId xmlns:a16="http://schemas.microsoft.com/office/drawing/2014/main" id="{9774E9C1-677B-4EFE-A158-2E00C2651399}"/>
+              </a:ext>
+            </a:extLst>
+          </p:cNvPr>
+          <p:cNvSpPr>
+            <a:spLocks noGrp="1"/>
+          </p:cNvSpPr>
+          <p:nvPr>
+            <p:ph type="body" sz="quarter" idx="14" hasCustomPrompt="1"/>
+          </p:nvPr>
+        </p:nvSpPr>
+        <p:spPr>
+          <a:xfrm>
+            <a:off x="3196326" y="1382026"/>
+            <a:ext cx="2761200" cy="4986000"/>
+          </a:xfrm>
+          <a:prstGeom prst="rect">
+            <a:avLst/>
+          </a:prstGeom>
+        </p:spPr>
+        <p:txBody>
+          <a:bodyPr lIns="0" tIns="0" rIns="0" bIns="0"/>
+          <a:lstStyle>
+            <a:lvl1pPr marL="0" indent="0">
+              <a:lnSpc>
+                <a:spcPct val="90000"/>
+              </a:lnSpc>
+              <a:spcBef>
+                <a:spcPts val="0"/>
+              </a:spcBef>
+              <a:spcAft>
+                <a:spcPts val="1200"/>
+              </a:spcAft>
+              <a:defRPr sz="1400">
+                <a:solidFill>
+                  <a:schemeClr val="tx1"/>
+                </a:solidFill>
+                <a:latin typeface="+mn-lt"/>
+              </a:defRPr>
+            </a:lvl1pPr>
+          </a:lstStyle>
+          <a:p>
+            <a:pPr lvl="0"/>
+            <a:r>
+              <a:rPr lang="en-US" dirty="0"/>
+              <a:t>Insert text</a:t>
+            </a:r>
+            <a:endParaRPr lang="en-GB" dirty="0"/>
+          </a:p>
+        </p:txBody>
+      </p:sp>
+      <p:sp>
+        <p:nvSpPr>
+          <p:cNvPr id="16" name="Text Placeholder 11">
+            <a:extLst>
+              <a:ext uri="{FF2B5EF4-FFF2-40B4-BE49-F238E27FC236}">
+                <a16:creationId xmlns:a16="http://schemas.microsoft.com/office/drawing/2014/main" id="{A198913B-55CA-4D8D-9544-D90FE4883430}"/>
+              </a:ext>
+            </a:extLst>
+          </p:cNvPr>
+          <p:cNvSpPr>
+            <a:spLocks noGrp="1"/>
+          </p:cNvSpPr>
+          <p:nvPr>
+            <p:ph type="body" sz="quarter" idx="15" hasCustomPrompt="1"/>
+          </p:nvPr>
+        </p:nvSpPr>
+        <p:spPr>
+          <a:xfrm>
+            <a:off x="6130889" y="1382026"/>
+            <a:ext cx="2761200" cy="4986000"/>
+          </a:xfrm>
+          <a:prstGeom prst="rect">
+            <a:avLst/>
+          </a:prstGeom>
+        </p:spPr>
+        <p:txBody>
+          <a:bodyPr lIns="0" tIns="0" rIns="0" bIns="0"/>
+          <a:lstStyle>
+            <a:lvl1pPr marL="0" indent="0">
+              <a:lnSpc>
+                <a:spcPct val="90000"/>
+              </a:lnSpc>
+              <a:spcBef>
+                <a:spcPts val="0"/>
+              </a:spcBef>
+              <a:spcAft>
+                <a:spcPts val="1200"/>
+              </a:spcAft>
+              <a:defRPr sz="1400">
+                <a:solidFill>
+                  <a:schemeClr val="tx1"/>
+                </a:solidFill>
+                <a:latin typeface="+mn-lt"/>
+              </a:defRPr>
+            </a:lvl1pPr>
+          </a:lstStyle>
+          <a:p>
+            <a:pPr lvl="0"/>
+            <a:r>
+              <a:rPr lang="en-US" dirty="0"/>
+              <a:t>Insert text</a:t>
+            </a:r>
+            <a:endParaRPr lang="en-GB" dirty="0"/>
+          </a:p>
+        </p:txBody>
+      </p:sp>
+    </p:spTree>
+    <p:extLst>
+      <p:ext uri="{BB962C8B-B14F-4D97-AF65-F5344CB8AC3E}">
+        <p14:creationId xmlns:p14="http://schemas.microsoft.com/office/powerpoint/2010/main" val="3487409176"/>
+      </p:ext>
+    </p:extLst>
+  </p:cSld>
+  <p:clrMapOvr>
+    <a:masterClrMapping/>
+  </p:clrMapOvr>
+  <p:transition/>
+  <p:extLst>
+    <p:ext uri="{DCECCB84-F9BA-43D5-87BE-67443E8EF086}">
+      <p15:sldGuideLst xmlns:p15="http://schemas.microsoft.com/office/powerpoint/2012/main">
+        <p15:guide id="1" orient="horz" pos="119">
+          <p15:clr>
+            <a:srgbClr val="FBAE40"/>
+          </p15:clr>
+        </p15:guide>
+        <p15:guide id="2" orient="horz" pos="4110">
+          <p15:clr>
+            <a:srgbClr val="FBAE40"/>
+          </p15:clr>
+        </p15:guide>
+        <p15:guide id="3" pos="5284">
+          <p15:clr>
+            <a:srgbClr val="FBAE40"/>
+          </p15:clr>
+        </p15:guide>
+        <p15:guide id="4" pos="158">
+          <p15:clr>
+            <a:srgbClr val="FBAE40"/>
+          </p15:clr>
+        </p15:guide>
+        <p15:guide id="5" pos="5602">
+          <p15:clr>
+            <a:srgbClr val="FBAE40"/>
+          </p15:clr>
+        </p15:guide>
+        <p15:guide id="6" orient="horz" pos="1570">
+          <p15:clr>
+            <a:srgbClr val="FBAE40"/>
+          </p15:clr>
+        </p15:guide>
+        <p15:guide id="7" orient="horz" pos="1185">
+          <p15:clr>
+            <a:srgbClr val="FBAE40"/>
+          </p15:clr>
+        </p15:guide>
+        <p15:guide id="8" orient="horz" pos="459">
+          <p15:clr>
+            <a:srgbClr val="FBAE40"/>
+          </p15:clr>
+        </p15:guide>
+        <p15:guide id="9" orient="horz" pos="323">
+          <p15:clr>
+            <a:srgbClr val="FBAE40"/>
+          </p15:clr>
+        </p15:guide>
+      </p15:sldGuideLst>
+    </p:ext>
+  </p:extLst>
+</p:sldLayout>
+</file>
+
 <file path=ppt/slideLayouts/slideLayout2.xml><?xml version="1.0" encoding="utf-8"?>
 <p:sldLayout xmlns:a="http://schemas.openxmlformats.org/drawingml/2006/main" xmlns:r="http://schemas.openxmlformats.org/officeDocument/2006/relationships" xmlns:p="http://schemas.openxmlformats.org/presentationml/2006/main" preserve="1">
   <p:cSld name="Section Divider">
@@ -10325,8 +11190,8 @@
         </p:nvSpPr>
         <p:spPr>
           <a:xfrm>
-            <a:off x="250825" y="1268414"/>
-            <a:ext cx="8642350" cy="5113338"/>
+            <a:off x="250825" y="1736725"/>
+            <a:ext cx="8642350" cy="4645026"/>
           </a:xfrm>
           <a:prstGeom prst="rect">
             <a:avLst/>
@@ -10644,7 +11509,7 @@
         <p:spPr>
           <a:xfrm>
             <a:off x="250828" y="727200"/>
-            <a:ext cx="8642348" cy="443198"/>
+            <a:ext cx="8642348" cy="886397"/>
           </a:xfrm>
           <a:prstGeom prst="rect">
             <a:avLst/>
@@ -10673,6 +11538,13 @@
               <a:rPr lang="en-GB" dirty="0"/>
               <a:t>Briefing and Signals</a:t>
             </a:r>
+            <a:br>
+              <a:rPr lang="en-GB" dirty="0"/>
+            </a:br>
+            <a:r>
+              <a:rPr lang="en-GB" dirty="0"/>
+              <a:t>(second line)</a:t>
+            </a:r>
             <a:endParaRPr lang="en-US" dirty="0"/>
           </a:p>
         </p:txBody>
@@ -10690,17 +11562,17 @@
   <p:extLst>
     <p:ext uri="{DCECCB84-F9BA-43D5-87BE-67443E8EF086}">
       <p15:sldGuideLst xmlns:p15="http://schemas.microsoft.com/office/powerpoint/2012/main">
-        <p15:guide id="1" orient="horz" pos="799" userDrawn="1">
-          <p15:clr>
-            <a:srgbClr val="FBAE40"/>
-          </p15:clr>
-        </p15:guide>
         <p15:guide id="2" orient="horz" pos="4020" userDrawn="1">
           <p15:clr>
             <a:srgbClr val="FBAE40"/>
           </p15:clr>
         </p15:guide>
         <p15:guide id="3" orient="horz" pos="323" userDrawn="1">
+          <p15:clr>
+            <a:srgbClr val="FBAE40"/>
+          </p15:clr>
+        </p15:guide>
+        <p15:guide id="4" orient="horz" pos="1094" userDrawn="1">
           <p15:clr>
             <a:srgbClr val="FBAE40"/>
           </p15:clr>
@@ -25659,11 +26531,11 @@
     <p:sldLayoutId id="2147484064" r:id="rId2"/>
     <p:sldLayoutId id="2147484065" r:id="rId3"/>
     <p:sldLayoutId id="2147484066" r:id="rId4"/>
-    <p:sldLayoutId id="2147484068" r:id="rId5"/>
-    <p:sldLayoutId id="2147484069" r:id="rId6"/>
-    <p:sldLayoutId id="2147483656" r:id="rId7"/>
-    <p:sldLayoutId id="2147484079" r:id="rId8"/>
-    <p:sldLayoutId id="2147484080" r:id="rId9"/>
+    <p:sldLayoutId id="2147484074" r:id="rId5"/>
+    <p:sldLayoutId id="2147484068" r:id="rId6"/>
+    <p:sldLayoutId id="2147484069" r:id="rId7"/>
+    <p:sldLayoutId id="2147484060" r:id="rId8"/>
+    <p:sldLayoutId id="2147484077" r:id="rId9"/>
   </p:sldLayoutIdLst>
   <p:txStyles>
     <p:titleStyle>
@@ -26066,7 +26938,7 @@
 </p:sld>
 </file>
 
-<file path=ppt/slides/slide2.xml><?xml version="1.0" encoding="utf-8"?>
+<file path=ppt/slides/slide10.xml><?xml version="1.0" encoding="utf-8"?>
 <p:sld xmlns:a="http://schemas.openxmlformats.org/drawingml/2006/main" xmlns:r="http://schemas.openxmlformats.org/officeDocument/2006/relationships" xmlns:p="http://schemas.openxmlformats.org/presentationml/2006/main">
   <p:cSld>
     <p:spTree>
@@ -26085,10 +26957,270 @@
       </p:grpSpPr>
       <p:sp>
         <p:nvSpPr>
-          <p:cNvPr id="9" name="Text Placeholder 8">
+          <p:cNvPr id="4" name="Text Placeholder 3">
             <a:extLst>
               <a:ext uri="{FF2B5EF4-FFF2-40B4-BE49-F238E27FC236}">
-                <a16:creationId xmlns:a16="http://schemas.microsoft.com/office/drawing/2014/main" id="{9445F9D9-0C13-4EDD-838E-062B771FE3A6}"/>
+                <a16:creationId xmlns:a16="http://schemas.microsoft.com/office/drawing/2014/main" id="{9085BD27-5E0B-4AF1-82E4-2FCE3C656DF8}"/>
+              </a:ext>
+            </a:extLst>
+          </p:cNvPr>
+          <p:cNvSpPr>
+            <a:spLocks noGrp="1"/>
+          </p:cNvSpPr>
+          <p:nvPr>
+            <p:ph type="body" sz="quarter" idx="10"/>
+          </p:nvPr>
+        </p:nvSpPr>
+        <p:spPr>
+          <a:xfrm>
+            <a:off x="250825" y="5270691"/>
+            <a:ext cx="8642350" cy="276999"/>
+          </a:xfrm>
+        </p:spPr>
+        <p:txBody>
+          <a:bodyPr/>
+          <a:lstStyle/>
+          <a:p>
+            <a:r>
+              <a:rPr lang="en-GB" dirty="0">
+                <a:hlinkClick r:id="rId2">
+                  <a:extLst>
+                    <a:ext uri="{A12FA001-AC4F-418D-AE19-62706E023703}">
+                      <ahyp:hlinkClr xmlns:ahyp="http://schemas.microsoft.com/office/drawing/2018/hyperlinkcolor" val="tx"/>
+                    </a:ext>
+                  </a:extLst>
+                </a:hlinkClick>
+              </a:rPr>
+              <a:t>collision-help@foresightfactory.co</a:t>
+            </a:r>
+            <a:endParaRPr lang="en-GB" dirty="0"/>
+          </a:p>
+        </p:txBody>
+      </p:sp>
+    </p:spTree>
+    <p:extLst>
+      <p:ext uri="{BB962C8B-B14F-4D97-AF65-F5344CB8AC3E}">
+        <p14:creationId xmlns:p14="http://schemas.microsoft.com/office/powerpoint/2010/main" val="3566619164"/>
+      </p:ext>
+    </p:extLst>
+  </p:cSld>
+  <p:clrMapOvr>
+    <a:masterClrMapping/>
+  </p:clrMapOvr>
+</p:sld>
+</file>
+
+<file path=ppt/slides/slide2.xml><?xml version="1.0" encoding="utf-8"?>
+<p:sld xmlns:a="http://schemas.openxmlformats.org/drawingml/2006/main" xmlns:r="http://schemas.openxmlformats.org/officeDocument/2006/relationships" xmlns:p="http://schemas.openxmlformats.org/presentationml/2006/main">
+  <p:cSld>
+    <p:bg>
+      <p:bgPr>
+        <a:blipFill dpi="0" rotWithShape="1">
+          <a:blip r:embed="rId2" cstate="email">
+            <a:lum/>
+            <a:extLst>
+              <a:ext uri="{28A0092B-C50C-407E-A947-70E740481C1C}">
+                <a14:useLocalDpi xmlns:a14="http://schemas.microsoft.com/office/drawing/2010/main"/>
+              </a:ext>
+            </a:extLst>
+          </a:blip>
+          <a:srcRect/>
+          <a:stretch>
+            <a:fillRect/>
+          </a:stretch>
+        </a:blipFill>
+        <a:effectLst/>
+      </p:bgPr>
+    </p:bg>
+    <p:spTree>
+      <p:nvGrpSpPr>
+        <p:cNvPr id="1" name=""/>
+        <p:cNvGrpSpPr/>
+        <p:nvPr/>
+      </p:nvGrpSpPr>
+      <p:grpSpPr>
+        <a:xfrm>
+          <a:off x="0" y="0"/>
+          <a:ext cx="0" cy="0"/>
+          <a:chOff x="0" y="0"/>
+          <a:chExt cx="0" cy="0"/>
+        </a:xfrm>
+      </p:grpSpPr>
+      <p:sp>
+        <p:nvSpPr>
+          <p:cNvPr id="3" name="Text Placeholder 2"/>
+          <p:cNvSpPr>
+            <a:spLocks noGrp="1"/>
+          </p:cNvSpPr>
+          <p:nvPr>
+            <p:ph type="body" sz="quarter" idx="11"/>
+          </p:nvPr>
+        </p:nvSpPr>
+        <p:spPr/>
+        <p:txBody>
+          <a:bodyPr/>
+          <a:lstStyle/>
+          <a:p>
+            <a:r>
+              <a:rPr lang="en-GB" dirty="0"/>
+              <a:t>Contactless credit/debit cards, NFC- and web-enabled phones and digital wallets.</a:t>
+            </a:r>
+          </a:p>
+        </p:txBody>
+      </p:sp>
+      <p:sp>
+        <p:nvSpPr>
+          <p:cNvPr id="2" name="Text Placeholder 1"/>
+          <p:cNvSpPr>
+            <a:spLocks noGrp="1"/>
+          </p:cNvSpPr>
+          <p:nvPr>
+            <p:ph type="body" sz="quarter" idx="10"/>
+          </p:nvPr>
+        </p:nvSpPr>
+        <p:spPr/>
+        <p:txBody>
+          <a:bodyPr/>
+          <a:lstStyle/>
+          <a:p>
+            <a:r>
+              <a:rPr lang="en-GB" dirty="0"/>
+              <a:t>Abcdefghijklmnopqrstuvwxyz12345</a:t>
+            </a:r>
+          </a:p>
+        </p:txBody>
+      </p:sp>
+      <p:sp>
+        <p:nvSpPr>
+          <p:cNvPr id="4" name="Isosceles Triangle 3">
+            <a:extLst>
+              <a:ext uri="{FF2B5EF4-FFF2-40B4-BE49-F238E27FC236}">
+                <a16:creationId xmlns:a16="http://schemas.microsoft.com/office/drawing/2014/main" id="{E14E49DD-6BD6-AE88-54E0-B4E3BFBA7A45}"/>
+              </a:ext>
+            </a:extLst>
+          </p:cNvPr>
+          <p:cNvSpPr/>
+          <p:nvPr/>
+        </p:nvSpPr>
+        <p:spPr>
+          <a:xfrm rot="10800000">
+            <a:off x="7668344" y="-1"/>
+            <a:ext cx="1476164" cy="1052736"/>
+          </a:xfrm>
+          <a:prstGeom prst="triangle">
+            <a:avLst>
+              <a:gd name="adj" fmla="val 0"/>
+            </a:avLst>
+          </a:prstGeom>
+          <a:solidFill>
+            <a:schemeClr val="accent1"/>
+          </a:solidFill>
+          <a:ln>
+            <a:noFill/>
+          </a:ln>
+          <a:effectLst/>
+        </p:spPr>
+        <p:style>
+          <a:lnRef idx="1">
+            <a:schemeClr val="accent1"/>
+          </a:lnRef>
+          <a:fillRef idx="3">
+            <a:schemeClr val="accent1"/>
+          </a:fillRef>
+          <a:effectRef idx="2">
+            <a:schemeClr val="accent1"/>
+          </a:effectRef>
+          <a:fontRef idx="minor">
+            <a:schemeClr val="lt1"/>
+          </a:fontRef>
+        </p:style>
+        <p:txBody>
+          <a:bodyPr rtlCol="0" anchor="ctr"/>
+          <a:lstStyle/>
+          <a:p>
+            <a:pPr algn="ctr"/>
+            <a:endParaRPr lang="en-GB" dirty="0"/>
+          </a:p>
+        </p:txBody>
+      </p:sp>
+      <p:sp>
+        <p:nvSpPr>
+          <p:cNvPr id="8" name="TextBox 7">
+            <a:extLst>
+              <a:ext uri="{FF2B5EF4-FFF2-40B4-BE49-F238E27FC236}">
+                <a16:creationId xmlns:a16="http://schemas.microsoft.com/office/drawing/2014/main" id="{74BAF5FD-3904-EAE7-2BE8-B0E16EE59AC2}"/>
+              </a:ext>
+            </a:extLst>
+          </p:cNvPr>
+          <p:cNvSpPr txBox="1"/>
+          <p:nvPr/>
+        </p:nvSpPr>
+        <p:spPr>
+          <a:xfrm>
+            <a:off x="8460432" y="44624"/>
+            <a:ext cx="683568" cy="646331"/>
+          </a:xfrm>
+          <a:prstGeom prst="rect">
+            <a:avLst/>
+          </a:prstGeom>
+          <a:noFill/>
+        </p:spPr>
+        <p:txBody>
+          <a:bodyPr wrap="square" rtlCol="0">
+            <a:spAutoFit/>
+          </a:bodyPr>
+          <a:lstStyle/>
+          <a:p>
+            <a:pPr algn="ctr"/>
+            <a:r>
+              <a:rPr lang="en-GB" sz="3600" b="1" dirty="0">
+                <a:solidFill>
+                  <a:schemeClr val="bg1"/>
+                </a:solidFill>
+                <a:latin typeface="Arial" panose="020B0604020202020204" pitchFamily="34" charset="0"/>
+                <a:cs typeface="Arial" panose="020B0604020202020204" pitchFamily="34" charset="0"/>
+              </a:rPr>
+              <a:t>2</a:t>
+            </a:r>
+          </a:p>
+        </p:txBody>
+      </p:sp>
+    </p:spTree>
+    <p:extLst>
+      <p:ext uri="{BB962C8B-B14F-4D97-AF65-F5344CB8AC3E}">
+        <p14:creationId xmlns:p14="http://schemas.microsoft.com/office/powerpoint/2010/main" val="2852840075"/>
+      </p:ext>
+    </p:extLst>
+  </p:cSld>
+  <p:clrMapOvr>
+    <a:masterClrMapping/>
+  </p:clrMapOvr>
+</p:sld>
+</file>
+
+<file path=ppt/slides/slide3.xml><?xml version="1.0" encoding="utf-8"?>
+<p:sld xmlns:a="http://schemas.openxmlformats.org/drawingml/2006/main" xmlns:r="http://schemas.openxmlformats.org/officeDocument/2006/relationships" xmlns:p="http://schemas.openxmlformats.org/presentationml/2006/main">
+  <p:cSld>
+    <p:spTree>
+      <p:nvGrpSpPr>
+        <p:cNvPr id="1" name=""/>
+        <p:cNvGrpSpPr/>
+        <p:nvPr/>
+      </p:nvGrpSpPr>
+      <p:grpSpPr>
+        <a:xfrm>
+          <a:off x="0" y="0"/>
+          <a:ext cx="0" cy="0"/>
+          <a:chOff x="0" y="0"/>
+          <a:chExt cx="0" cy="0"/>
+        </a:xfrm>
+      </p:grpSpPr>
+      <p:sp>
+        <p:nvSpPr>
+          <p:cNvPr id="5" name="Text Placeholder 4">
+            <a:extLst>
+              <a:ext uri="{FF2B5EF4-FFF2-40B4-BE49-F238E27FC236}">
+                <a16:creationId xmlns:a16="http://schemas.microsoft.com/office/drawing/2014/main" id="{8058E7F8-A0D7-4821-808E-5C3FFD0C2942}"/>
               </a:ext>
             </a:extLst>
           </p:cNvPr>
@@ -26118,7 +27250,12 @@
             <p:ph type="body" sz="quarter" idx="11"/>
           </p:nvPr>
         </p:nvSpPr>
-        <p:spPr/>
+        <p:spPr>
+          <a:xfrm>
+            <a:off x="250825" y="1736725"/>
+            <a:ext cx="8642350" cy="4645026"/>
+          </a:xfrm>
+        </p:spPr>
         <p:txBody>
           <a:bodyPr/>
           <a:lstStyle/>
@@ -26207,14 +27344,19 @@
             <p:ph type="title"/>
           </p:nvPr>
         </p:nvSpPr>
-        <p:spPr/>
+        <p:spPr>
+          <a:xfrm>
+            <a:off x="250828" y="727200"/>
+            <a:ext cx="8642348" cy="886397"/>
+          </a:xfrm>
+        </p:spPr>
         <p:txBody>
           <a:bodyPr/>
           <a:lstStyle/>
           <a:p>
             <a:r>
               <a:rPr lang="en-GB" dirty="0"/>
-              <a:t>Test Header</a:t>
+              <a:t>A very long title to test breaking over two lines works correctly</a:t>
             </a:r>
           </a:p>
         </p:txBody>
@@ -26222,7 +27364,7 @@
     </p:spTree>
     <p:extLst>
       <p:ext uri="{BB962C8B-B14F-4D97-AF65-F5344CB8AC3E}">
-        <p14:creationId xmlns:p14="http://schemas.microsoft.com/office/powerpoint/2010/main" val="4279913766"/>
+        <p14:creationId xmlns:p14="http://schemas.microsoft.com/office/powerpoint/2010/main" val="3054531529"/>
       </p:ext>
     </p:extLst>
   </p:cSld>
@@ -26232,7 +27374,992 @@
 </p:sld>
 </file>
 
-<file path=ppt/slides/slide3.xml><?xml version="1.0" encoding="utf-8"?>
+<file path=ppt/slides/slide4.xml><?xml version="1.0" encoding="utf-8"?>
+<p:sld xmlns:a="http://schemas.openxmlformats.org/drawingml/2006/main" xmlns:r="http://schemas.openxmlformats.org/officeDocument/2006/relationships" xmlns:p="http://schemas.openxmlformats.org/presentationml/2006/main">
+  <p:cSld>
+    <p:spTree>
+      <p:nvGrpSpPr>
+        <p:cNvPr id="1" name=""/>
+        <p:cNvGrpSpPr/>
+        <p:nvPr/>
+      </p:nvGrpSpPr>
+      <p:grpSpPr>
+        <a:xfrm>
+          <a:off x="0" y="0"/>
+          <a:ext cx="0" cy="0"/>
+          <a:chOff x="0" y="0"/>
+          <a:chExt cx="0" cy="0"/>
+        </a:xfrm>
+      </p:grpSpPr>
+      <p:sp>
+        <p:nvSpPr>
+          <p:cNvPr id="2" name="Text Placeholder 1">
+            <a:extLst>
+              <a:ext uri="{FF2B5EF4-FFF2-40B4-BE49-F238E27FC236}">
+                <a16:creationId xmlns:a16="http://schemas.microsoft.com/office/drawing/2014/main" id="{D5F0215C-822F-F876-1C36-259EB0C34B85}"/>
+              </a:ext>
+            </a:extLst>
+          </p:cNvPr>
+          <p:cNvSpPr>
+            <a:spLocks noGrp="1"/>
+          </p:cNvSpPr>
+          <p:nvPr>
+            <p:ph type="body" sz="quarter" idx="10"/>
+          </p:nvPr>
+        </p:nvSpPr>
+        <p:spPr/>
+        <p:txBody>
+          <a:bodyPr/>
+          <a:lstStyle/>
+          <a:p>
+            <a:r>
+              <a:rPr lang="en-GB" dirty="0"/>
+              <a:t>Source: Foresight Factory</a:t>
+            </a:r>
+          </a:p>
+        </p:txBody>
+      </p:sp>
+      <p:sp>
+        <p:nvSpPr>
+          <p:cNvPr id="3" name="Text Placeholder 2">
+            <a:extLst>
+              <a:ext uri="{FF2B5EF4-FFF2-40B4-BE49-F238E27FC236}">
+                <a16:creationId xmlns:a16="http://schemas.microsoft.com/office/drawing/2014/main" id="{4CDB0723-7D37-E408-C913-18557A83A58F}"/>
+              </a:ext>
+            </a:extLst>
+          </p:cNvPr>
+          <p:cNvSpPr>
+            <a:spLocks noGrp="1"/>
+          </p:cNvSpPr>
+          <p:nvPr>
+            <p:ph type="body" sz="quarter" idx="12"/>
+          </p:nvPr>
+        </p:nvSpPr>
+        <p:spPr>
+          <a:xfrm>
+            <a:off x="250825" y="331200"/>
+            <a:ext cx="8137525" cy="184666"/>
+          </a:xfrm>
+        </p:spPr>
+        <p:txBody>
+          <a:bodyPr/>
+          <a:lstStyle/>
+          <a:p>
+            <a:r>
+              <a:rPr lang="en-GB" dirty="0"/>
+              <a:t> </a:t>
+            </a:r>
+          </a:p>
+        </p:txBody>
+      </p:sp>
+      <p:sp>
+        <p:nvSpPr>
+          <p:cNvPr id="4" name="Text Placeholder 3">
+            <a:extLst>
+              <a:ext uri="{FF2B5EF4-FFF2-40B4-BE49-F238E27FC236}">
+                <a16:creationId xmlns:a16="http://schemas.microsoft.com/office/drawing/2014/main" id="{C32C79AA-F94C-A82F-3324-FC9956A233A7}"/>
+              </a:ext>
+            </a:extLst>
+          </p:cNvPr>
+          <p:cNvSpPr>
+            <a:spLocks noGrp="1"/>
+          </p:cNvSpPr>
+          <p:nvPr>
+            <p:ph type="body" sz="quarter" idx="13"/>
+          </p:nvPr>
+        </p:nvSpPr>
+        <p:spPr>
+          <a:xfrm>
+            <a:off x="250824" y="152636"/>
+            <a:ext cx="8137526" cy="184666"/>
+          </a:xfrm>
+        </p:spPr>
+        <p:txBody>
+          <a:bodyPr/>
+          <a:lstStyle/>
+          <a:p>
+            <a:r>
+              <a:rPr lang="en-GB" dirty="0"/>
+              <a:t> </a:t>
+            </a:r>
+          </a:p>
+        </p:txBody>
+      </p:sp>
+      <!-- Start of Column -->
+      <p:sp>
+        <p:nvSpPr>
+          <p:cNvPr id="5" name="Text Placeholder 4">
+            <a:extLst>
+              <a:ext uri="{FF2B5EF4-FFF2-40B4-BE49-F238E27FC236}">
+                <a16:creationId xmlns:a16="http://schemas.microsoft.com/office/drawing/2014/main" id="{5A2A17F5-BDB6-3277-82F6-DE5BCCE429BF}"/>
+              </a:ext>
+            </a:extLst>
+          </p:cNvPr>
+          <p:cNvSpPr>
+            <a:spLocks noGrp="1"/>
+          </p:cNvSpPr>
+          <p:nvPr>
+            <p:ph type="body" sz="quarter" idx="11"/>
+          </p:nvPr>
+        </p:nvSpPr>
+        <p:spPr/>
+        <p:txBody>
+          <a:bodyPr/>
+          <a:lstStyle/>
+          <a:p>
+            <a:pPr marL="228600" indent="-228600">
+              <a:buSzPct val="100000"/>
+              <a:buFont typeface="+mj-lt"/>
+              <a:buAutoNum type="arabicPeriod" startAt="4"/>
+            </a:pPr>
+            <a:r>
+              <a:rPr lang="en-GB" sz="1200" b="1" dirty="0">
+                <a:hlinkClick r:id="rId100"/>
+              </a:rPr>
+              <a:t>Title 1</a:t>
+            </a:r>
+            <a:r>
+              <a:rPr lang="en-GB" sz="1200" dirty="0"/>
+              <a:t>: </a:t>
+            </a:r>
+            <a:r>
+              <a:rPr lang="en-GB" sz="1200" i="0" dirty="0">
+                <a:effectLst/>
+                <a:latin typeface="Georgia" panose="02040502050405020303" pitchFamily="18" charset="0"/>
+              </a:rPr>
+              <a:t>contents 1</a:t>
+            </a:r>
+            <a:endParaRPr lang="en-GB" sz="1200" dirty="0"/>
+          </a:p>
+          <a:p>
+            <a:pPr marL="228600" indent="-228600">
+              <a:buSzPct val="100000"/>
+              <a:buFont typeface="+mj-lt"/>
+              <a:buAutoNum type="arabicPeriod" startAt="4"/>
+            </a:pPr>
+            <a:r>
+              <a:rPr lang="en-GB" sz="1200" b="1" dirty="0">
+                <a:hlinkClick r:id="rId101"/>
+              </a:rPr>
+              <a:t>Title 2</a:t>
+            </a:r>
+            <a:r>
+              <a:rPr lang="en-GB" sz="1200" dirty="0"/>
+              <a:t>: </a:t>
+            </a:r>
+            <a:r>
+              <a:rPr lang="en-GB" sz="1200" i="0" dirty="0">
+                <a:effectLst/>
+                <a:latin typeface="Georgia" panose="02040502050405020303" pitchFamily="18" charset="0"/>
+              </a:rPr>
+              <a:t>contents 2</a:t>
+            </a:r>
+            <a:endParaRPr lang="en-GB" sz="1200" dirty="0"/>
+          </a:p>
+          <a:p>
+            <a:pPr marL="228600" indent="-228600">
+              <a:buSzPct val="100000"/>
+              <a:buFont typeface="+mj-lt"/>
+              <a:buAutoNum type="arabicPeriod" startAt="4"/>
+            </a:pPr>
+            <a:r>
+              <a:rPr lang="en-GB" sz="1200" b="1" dirty="0">
+                <a:hlinkClick r:id="rId102"/>
+              </a:rPr>
+              <a:t>Title 3</a:t>
+            </a:r>
+            <a:r>
+              <a:rPr lang="en-GB" sz="1200" dirty="0"/>
+              <a:t>: </a:t>
+            </a:r>
+            <a:r>
+              <a:rPr lang="en-GB" sz="1200" i="0" dirty="0">
+                <a:effectLst/>
+                <a:latin typeface="Georgia" panose="02040502050405020303" pitchFamily="18" charset="0"/>
+              </a:rPr>
+              <a:t>contents 3</a:t>
+            </a:r>
+            <a:endParaRPr lang="en-GB" sz="1200" dirty="0"/>
+          </a:p>
+          <a:p>
+            <a:pPr marL="228600" indent="-228600">
+              <a:buSzPct val="100000"/>
+              <a:buFont typeface="+mj-lt"/>
+              <a:buAutoNum type="arabicPeriod" startAt="4"/>
+            </a:pPr>
+            <a:r>
+              <a:rPr lang="en-GB" sz="1200" b="1" dirty="0">
+                <a:hlinkClick r:id="rId103"/>
+              </a:rPr>
+              <a:t>Title 4</a:t>
+            </a:r>
+            <a:r>
+              <a:rPr lang="en-GB" sz="1200" dirty="0"/>
+              <a:t>: </a:t>
+            </a:r>
+            <a:r>
+              <a:rPr lang="en-GB" sz="1200" i="0" dirty="0">
+                <a:effectLst/>
+                <a:latin typeface="Georgia" panose="02040502050405020303" pitchFamily="18" charset="0"/>
+              </a:rPr>
+              <a:t>contents 4</a:t>
+            </a:r>
+            <a:endParaRPr lang="en-GB" sz="1200" dirty="0"/>
+          </a:p>
+          <a:p>
+            <a:pPr marL="228600" indent="-228600">
+              <a:buSzPct val="100000"/>
+              <a:buFont typeface="+mj-lt"/>
+              <a:buAutoNum type="arabicPeriod" startAt="4"/>
+            </a:pPr>
+            <a:r>
+              <a:rPr lang="en-GB" sz="1200" b="1" dirty="0">
+                <a:hlinkClick r:id="rId104"/>
+              </a:rPr>
+              <a:t>Title 5</a:t>
+            </a:r>
+            <a:r>
+              <a:rPr lang="en-GB" sz="1200" dirty="0"/>
+              <a:t>: </a:t>
+            </a:r>
+            <a:r>
+              <a:rPr lang="en-GB" sz="1200" i="0" dirty="0">
+                <a:effectLst/>
+                <a:latin typeface="Georgia" panose="02040502050405020303" pitchFamily="18" charset="0"/>
+              </a:rPr>
+              <a:t>contents 5</a:t>
+            </a:r>
+            <a:endParaRPr lang="en-GB" sz="1200" dirty="0"/>
+          </a:p>
+          <a:p>
+            <a:pPr marL="228600" indent="-228600">
+              <a:buSzPct val="100000"/>
+              <a:buFont typeface="+mj-lt"/>
+              <a:buAutoNum type="arabicPeriod" startAt="4"/>
+            </a:pPr>
+            <a:r>
+              <a:rPr lang="en-GB" sz="1200" b="1" dirty="0">
+                <a:hlinkClick r:id="rId105"/>
+              </a:rPr>
+              <a:t>Title 6</a:t>
+            </a:r>
+            <a:r>
+              <a:rPr lang="en-GB" sz="1200" dirty="0"/>
+              <a:t>: </a:t>
+            </a:r>
+            <a:r>
+              <a:rPr lang="en-GB" sz="1200" i="0" dirty="0">
+                <a:effectLst/>
+                <a:latin typeface="Georgia" panose="02040502050405020303" pitchFamily="18" charset="0"/>
+              </a:rPr>
+              <a:t>contents 6</a:t>
+            </a:r>
+            <a:endParaRPr lang="en-GB" sz="1200" dirty="0"/>
+          </a:p>
+          <a:p>
+            <a:pPr marL="228600" indent="-228600">
+              <a:buSzPct val="100000"/>
+              <a:buFont typeface="+mj-lt"/>
+              <a:buAutoNum type="arabicPeriod" startAt="4"/>
+            </a:pPr>
+            <a:r>
+              <a:rPr lang="en-GB" sz="1200" b="1" dirty="0">
+                <a:hlinkClick r:id="rId106"/>
+              </a:rPr>
+              <a:t>Title 7</a:t>
+            </a:r>
+            <a:r>
+              <a:rPr lang="en-GB" sz="1200" dirty="0"/>
+              <a:t>: </a:t>
+            </a:r>
+            <a:r>
+              <a:rPr lang="en-GB" sz="1200" i="0" dirty="0">
+                <a:effectLst/>
+                <a:latin typeface="Georgia" panose="02040502050405020303" pitchFamily="18" charset="0"/>
+              </a:rPr>
+              <a:t>contents 7</a:t>
+            </a:r>
+            <a:endParaRPr lang="en-GB" sz="1200" dirty="0"/>
+          </a:p>
+          <a:p>
+            <a:endParaRPr lang="en-GB" sz="1200" dirty="0"/>
+          </a:p>
+        </p:txBody>
+      </p:sp>
+      <p:sp>
+        <p:nvSpPr>
+          <p:cNvPr id="5" name="Text Placeholder 4">
+            <a:extLst>
+              <a:ext uri="{FF2B5EF4-FFF2-40B4-BE49-F238E27FC236}">
+                <a16:creationId xmlns:a16="http://schemas.microsoft.com/office/drawing/2014/main" id="{5A2A17F5-BDB6-3277-82F6-DE5BCCE429BF}"/>
+              </a:ext>
+            </a:extLst>
+          </p:cNvPr>
+          <p:cNvSpPr>
+            <a:spLocks noGrp="1"/>
+          </p:cNvSpPr>
+          <p:nvPr>
+            <p:ph type="body" sz="quarter" idx="14"/>
+          </p:nvPr>
+        </p:nvSpPr>
+        <p:spPr/>
+        <p:txBody>
+          <a:bodyPr/>
+          <a:lstStyle/>
+          <a:p>
+            <a:pPr marL="228600" indent="-228600">
+              <a:buSzPct val="100000"/>
+              <a:buFont typeface="+mj-lt"/>
+              <a:buAutoNum type="arabicPeriod" startAt="11"/>
+            </a:pPr>
+            <a:r>
+              <a:rPr lang="en-GB" sz="1200" b="1" dirty="0">
+                <a:hlinkClick r:id="rId100"/>
+              </a:rPr>
+              <a:t>Title 2</a:t>
+            </a:r>
+            <a:r>
+              <a:rPr lang="en-GB" sz="1200" dirty="0"/>
+              <a:t>: </a:t>
+            </a:r>
+            <a:r>
+              <a:rPr lang="en-GB" sz="1200" i="0" dirty="0">
+                <a:effectLst/>
+                <a:latin typeface="Georgia" panose="02040502050405020303" pitchFamily="18" charset="0"/>
+              </a:rPr>
+              <a:t>contents 2</a:t>
+            </a:r>
+            <a:endParaRPr lang="en-GB" sz="1200" dirty="0"/>
+          </a:p>
+          <a:p>
+            <a:pPr marL="228600" indent="-228600">
+              <a:buSzPct val="100000"/>
+              <a:buFont typeface="+mj-lt"/>
+              <a:buAutoNum type="arabicPeriod" startAt="11"/>
+            </a:pPr>
+            <a:r>
+              <a:rPr lang="en-GB" sz="1200" b="1" dirty="0">
+                <a:hlinkClick r:id="rId101"/>
+              </a:rPr>
+              <a:t>Title 4</a:t>
+            </a:r>
+            <a:r>
+              <a:rPr lang="en-GB" sz="1200" dirty="0"/>
+              <a:t>: </a:t>
+            </a:r>
+            <a:r>
+              <a:rPr lang="en-GB" sz="1200" i="0" dirty="0">
+                <a:effectLst/>
+                <a:latin typeface="Georgia" panose="02040502050405020303" pitchFamily="18" charset="0"/>
+              </a:rPr>
+              <a:t>contents 4</a:t>
+            </a:r>
+            <a:endParaRPr lang="en-GB" sz="1200" dirty="0"/>
+          </a:p>
+          <a:p>
+            <a:pPr marL="228600" indent="-228600">
+              <a:buSzPct val="100000"/>
+              <a:buFont typeface="+mj-lt"/>
+              <a:buAutoNum type="arabicPeriod" startAt="11"/>
+            </a:pPr>
+            <a:r>
+              <a:rPr lang="en-GB" sz="1200" b="1" dirty="0">
+                <a:hlinkClick r:id="rId102"/>
+              </a:rPr>
+              <a:t>Title 6</a:t>
+            </a:r>
+            <a:r>
+              <a:rPr lang="en-GB" sz="1200" dirty="0"/>
+              <a:t>: </a:t>
+            </a:r>
+            <a:r>
+              <a:rPr lang="en-GB" sz="1200" i="0" dirty="0">
+                <a:effectLst/>
+                <a:latin typeface="Georgia" panose="02040502050405020303" pitchFamily="18" charset="0"/>
+              </a:rPr>
+              <a:t>contents 6</a:t>
+            </a:r>
+            <a:endParaRPr lang="en-GB" sz="1200" dirty="0"/>
+          </a:p>
+          <a:p>
+            <a:pPr marL="228600" indent="-228600">
+              <a:buSzPct val="100000"/>
+              <a:buFont typeface="+mj-lt"/>
+              <a:buAutoNum type="arabicPeriod" startAt="11"/>
+            </a:pPr>
+            <a:r>
+              <a:rPr lang="en-GB" sz="1200" b="1" dirty="0">
+                <a:hlinkClick r:id="rId103"/>
+              </a:rPr>
+              <a:t>Title 8</a:t>
+            </a:r>
+            <a:r>
+              <a:rPr lang="en-GB" sz="1200" dirty="0"/>
+              <a:t>: </a:t>
+            </a:r>
+            <a:r>
+              <a:rPr lang="en-GB" sz="1200" i="0" dirty="0">
+                <a:effectLst/>
+                <a:latin typeface="Georgia" panose="02040502050405020303" pitchFamily="18" charset="0"/>
+              </a:rPr>
+              <a:t>contents 8</a:t>
+            </a:r>
+            <a:endParaRPr lang="en-GB" sz="1200" dirty="0"/>
+          </a:p>
+          <a:p>
+            <a:pPr marL="228600" indent="-228600">
+              <a:buSzPct val="100000"/>
+              <a:buFont typeface="+mj-lt"/>
+              <a:buAutoNum type="arabicPeriod" startAt="11"/>
+            </a:pPr>
+            <a:r>
+              <a:rPr lang="en-GB" sz="1200" b="1" dirty="0">
+                <a:hlinkClick r:id="rId104"/>
+              </a:rPr>
+              <a:t>Title 10</a:t>
+            </a:r>
+            <a:r>
+              <a:rPr lang="en-GB" sz="1200" dirty="0"/>
+              <a:t>: </a:t>
+            </a:r>
+            <a:r>
+              <a:rPr lang="en-GB" sz="1200" i="0" dirty="0">
+                <a:effectLst/>
+                <a:latin typeface="Georgia" panose="02040502050405020303" pitchFamily="18" charset="0"/>
+              </a:rPr>
+              <a:t>contents 10</a:t>
+            </a:r>
+            <a:endParaRPr lang="en-GB" sz="1200" dirty="0"/>
+          </a:p>
+          <a:p>
+            <a:pPr marL="228600" indent="-228600">
+              <a:buSzPct val="100000"/>
+              <a:buFont typeface="+mj-lt"/>
+              <a:buAutoNum type="arabicPeriod" startAt="11"/>
+            </a:pPr>
+            <a:r>
+              <a:rPr lang="en-GB" sz="1200" b="1" dirty="0">
+                <a:hlinkClick r:id="rId105"/>
+              </a:rPr>
+              <a:t>Title 12</a:t>
+            </a:r>
+            <a:r>
+              <a:rPr lang="en-GB" sz="1200" dirty="0"/>
+              <a:t>: </a:t>
+            </a:r>
+            <a:r>
+              <a:rPr lang="en-GB" sz="1200" i="0" dirty="0">
+                <a:effectLst/>
+                <a:latin typeface="Georgia" panose="02040502050405020303" pitchFamily="18" charset="0"/>
+              </a:rPr>
+              <a:t>contents 12</a:t>
+            </a:r>
+            <a:endParaRPr lang="en-GB" sz="1200" dirty="0"/>
+          </a:p>
+          <a:p>
+            <a:pPr marL="228600" indent="-228600">
+              <a:buSzPct val="100000"/>
+              <a:buFont typeface="+mj-lt"/>
+              <a:buAutoNum type="arabicPeriod" startAt="11"/>
+            </a:pPr>
+            <a:r>
+              <a:rPr lang="en-GB" sz="1200" b="1" dirty="0">
+                <a:hlinkClick r:id="rId106"/>
+              </a:rPr>
+              <a:t>Title 14</a:t>
+            </a:r>
+            <a:r>
+              <a:rPr lang="en-GB" sz="1200" dirty="0"/>
+              <a:t>: </a:t>
+            </a:r>
+            <a:r>
+              <a:rPr lang="en-GB" sz="1200" i="0" dirty="0">
+                <a:effectLst/>
+                <a:latin typeface="Georgia" panose="02040502050405020303" pitchFamily="18" charset="0"/>
+              </a:rPr>
+              <a:t>contents 14</a:t>
+            </a:r>
+            <a:endParaRPr lang="en-GB" sz="1200" dirty="0"/>
+          </a:p>
+          <a:p>
+            <a:endParaRPr lang="en-GB" sz="1200" dirty="0"/>
+          </a:p>
+        </p:txBody>
+      </p:sp>
+      <p:sp>
+        <p:nvSpPr>
+          <p:cNvPr id="5" name="Text Placeholder 4">
+            <a:extLst>
+              <a:ext uri="{FF2B5EF4-FFF2-40B4-BE49-F238E27FC236}">
+                <a16:creationId xmlns:a16="http://schemas.microsoft.com/office/drawing/2014/main" id="{5A2A17F5-BDB6-3277-82F6-DE5BCCE429BF}"/>
+              </a:ext>
+            </a:extLst>
+          </p:cNvPr>
+          <p:cNvSpPr>
+            <a:spLocks noGrp="1"/>
+          </p:cNvSpPr>
+          <p:nvPr>
+            <p:ph type="body" sz="quarter" idx="15"/>
+          </p:nvPr>
+        </p:nvSpPr>
+        <p:spPr/>
+        <p:txBody>
+          <a:bodyPr/>
+          <a:lstStyle/>
+          <a:p>
+            <a:pPr marL="228600" indent="-228600">
+              <a:buSzPct val="100000"/>
+              <a:buFont typeface="+mj-lt"/>
+              <a:buAutoNum type="arabicPeriod" startAt="18"/>
+            </a:pPr>
+            <a:r>
+              <a:rPr lang="en-GB" sz="1200" b="1" dirty="0">
+                <a:hlinkClick r:id="rId100"/>
+              </a:rPr>
+              <a:t>Title 3</a:t>
+            </a:r>
+            <a:r>
+              <a:rPr lang="en-GB" sz="1200" dirty="0"/>
+              <a:t>: </a:t>
+            </a:r>
+            <a:r>
+              <a:rPr lang="en-GB" sz="1200" i="0" dirty="0">
+                <a:effectLst/>
+                <a:latin typeface="Georgia" panose="02040502050405020303" pitchFamily="18" charset="0"/>
+              </a:rPr>
+              <a:t>contents 3</a:t>
+            </a:r>
+            <a:endParaRPr lang="en-GB" sz="1200" dirty="0"/>
+          </a:p>
+          <a:p>
+            <a:pPr marL="228600" indent="-228600">
+              <a:buSzPct val="100000"/>
+              <a:buFont typeface="+mj-lt"/>
+              <a:buAutoNum type="arabicPeriod" startAt="18"/>
+            </a:pPr>
+            <a:r>
+              <a:rPr lang="en-GB" sz="1200" b="1" dirty="0">
+                <a:hlinkClick r:id="rId101"/>
+              </a:rPr>
+              <a:t>Title 6</a:t>
+            </a:r>
+            <a:r>
+              <a:rPr lang="en-GB" sz="1200" dirty="0"/>
+              <a:t>: </a:t>
+            </a:r>
+            <a:r>
+              <a:rPr lang="en-GB" sz="1200" i="0" dirty="0">
+                <a:effectLst/>
+                <a:latin typeface="Georgia" panose="02040502050405020303" pitchFamily="18" charset="0"/>
+              </a:rPr>
+              <a:t>contents 6</a:t>
+            </a:r>
+            <a:endParaRPr lang="en-GB" sz="1200" dirty="0"/>
+          </a:p>
+          <a:p>
+            <a:pPr marL="228600" indent="-228600">
+              <a:buSzPct val="100000"/>
+              <a:buFont typeface="+mj-lt"/>
+              <a:buAutoNum type="arabicPeriod" startAt="18"/>
+            </a:pPr>
+            <a:r>
+              <a:rPr lang="en-GB" sz="1200" b="1" dirty="0">
+                <a:hlinkClick r:id="rId102"/>
+              </a:rPr>
+              <a:t>Title 9</a:t>
+            </a:r>
+            <a:r>
+              <a:rPr lang="en-GB" sz="1200" dirty="0"/>
+              <a:t>: </a:t>
+            </a:r>
+            <a:r>
+              <a:rPr lang="en-GB" sz="1200" i="0" dirty="0">
+                <a:effectLst/>
+                <a:latin typeface="Georgia" panose="02040502050405020303" pitchFamily="18" charset="0"/>
+              </a:rPr>
+              <a:t>contents 9</a:t>
+            </a:r>
+            <a:endParaRPr lang="en-GB" sz="1200" dirty="0"/>
+          </a:p>
+          <a:p>
+            <a:pPr marL="228600" indent="-228600">
+              <a:buSzPct val="100000"/>
+              <a:buFont typeface="+mj-lt"/>
+              <a:buAutoNum type="arabicPeriod" startAt="18"/>
+            </a:pPr>
+            <a:r>
+              <a:rPr lang="en-GB" sz="1200" b="1" dirty="0">
+                <a:hlinkClick r:id="rId103"/>
+              </a:rPr>
+              <a:t>Title 12</a:t>
+            </a:r>
+            <a:r>
+              <a:rPr lang="en-GB" sz="1200" dirty="0"/>
+              <a:t>: </a:t>
+            </a:r>
+            <a:r>
+              <a:rPr lang="en-GB" sz="1200" i="0" dirty="0">
+                <a:effectLst/>
+                <a:latin typeface="Georgia" panose="02040502050405020303" pitchFamily="18" charset="0"/>
+              </a:rPr>
+              <a:t>contents 12</a:t>
+            </a:r>
+            <a:endParaRPr lang="en-GB" sz="1200" dirty="0"/>
+          </a:p>
+          <a:p>
+            <a:pPr marL="228600" indent="-228600">
+              <a:buSzPct val="100000"/>
+              <a:buFont typeface="+mj-lt"/>
+              <a:buAutoNum type="arabicPeriod" startAt="18"/>
+            </a:pPr>
+            <a:r>
+              <a:rPr lang="en-GB" sz="1200" b="1" dirty="0">
+                <a:hlinkClick r:id="rId104"/>
+              </a:rPr>
+              <a:t>Title 15</a:t>
+            </a:r>
+            <a:r>
+              <a:rPr lang="en-GB" sz="1200" dirty="0"/>
+              <a:t>: </a:t>
+            </a:r>
+            <a:r>
+              <a:rPr lang="en-GB" sz="1200" i="0" dirty="0">
+                <a:effectLst/>
+                <a:latin typeface="Georgia" panose="02040502050405020303" pitchFamily="18" charset="0"/>
+              </a:rPr>
+              <a:t>contents 15</a:t>
+            </a:r>
+            <a:endParaRPr lang="en-GB" sz="1200" dirty="0"/>
+          </a:p>
+          <a:p>
+            <a:pPr marL="228600" indent="-228600">
+              <a:buSzPct val="100000"/>
+              <a:buFont typeface="+mj-lt"/>
+              <a:buAutoNum type="arabicPeriod" startAt="18"/>
+            </a:pPr>
+            <a:r>
+              <a:rPr lang="en-GB" sz="1200" b="1" dirty="0">
+                <a:hlinkClick r:id="rId105"/>
+              </a:rPr>
+              <a:t>Title 18</a:t>
+            </a:r>
+            <a:r>
+              <a:rPr lang="en-GB" sz="1200" dirty="0"/>
+              <a:t>: </a:t>
+            </a:r>
+            <a:r>
+              <a:rPr lang="en-GB" sz="1200" i="0" dirty="0">
+                <a:effectLst/>
+                <a:latin typeface="Georgia" panose="02040502050405020303" pitchFamily="18" charset="0"/>
+              </a:rPr>
+              <a:t>contents 18</a:t>
+            </a:r>
+            <a:endParaRPr lang="en-GB" sz="1200" dirty="0"/>
+          </a:p>
+          <a:p>
+            <a:pPr marL="228600" indent="-228600">
+              <a:buSzPct val="100000"/>
+              <a:buFont typeface="+mj-lt"/>
+              <a:buAutoNum type="arabicPeriod" startAt="18"/>
+            </a:pPr>
+            <a:r>
+              <a:rPr lang="en-GB" sz="1200" b="1" dirty="0">
+                <a:hlinkClick r:id="rId106"/>
+              </a:rPr>
+              <a:t>Title 21</a:t>
+            </a:r>
+            <a:r>
+              <a:rPr lang="en-GB" sz="1200" dirty="0"/>
+              <a:t>: </a:t>
+            </a:r>
+            <a:r>
+              <a:rPr lang="en-GB" sz="1200" i="0" dirty="0">
+                <a:effectLst/>
+                <a:latin typeface="Georgia" panose="02040502050405020303" pitchFamily="18" charset="0"/>
+              </a:rPr>
+              <a:t>contents 21</a:t>
+            </a:r>
+            <a:endParaRPr lang="en-GB" sz="1200" dirty="0"/>
+          </a:p>
+          <a:p>
+            <a:endParaRPr lang="en-GB" sz="1200" dirty="0"/>
+          </a:p>
+        </p:txBody>
+      </p:sp>
+      <!-- End of column -->
+      <p:sp>
+        <p:nvSpPr>
+          <p:cNvPr id="8" name="Rectangle 7">
+            <a:extLst>
+              <a:ext uri="{FF2B5EF4-FFF2-40B4-BE49-F238E27FC236}">
+                <a16:creationId xmlns:a16="http://schemas.microsoft.com/office/drawing/2014/main" id="{6978B03C-118E-0E63-41C4-53B24E253C92}"/>
+              </a:ext>
+            </a:extLst>
+          </p:cNvPr>
+          <p:cNvSpPr/>
+          <p:nvPr/>
+        </p:nvSpPr>
+        <p:spPr>
+          <a:xfrm>
+            <a:off x="250825" y="736369"/>
+            <a:ext cx="8613781" cy="430580"/>
+          </a:xfrm>
+          <a:prstGeom prst="rect">
+            <a:avLst/>
+          </a:prstGeom>
+          <a:solidFill>
+            <a:schemeClr val="accent1"/>
+          </a:solidFill>
+          <a:ln>
+            <a:noFill/>
+          </a:ln>
+        </p:spPr>
+        <p:style>
+          <a:lnRef idx="2">
+            <a:schemeClr val="accent1">
+              <a:shade val="50000"/>
+            </a:schemeClr>
+          </a:lnRef>
+          <a:fillRef idx="1">
+            <a:schemeClr val="accent1"/>
+          </a:fillRef>
+          <a:effectRef idx="0">
+            <a:schemeClr val="accent1"/>
+          </a:effectRef>
+          <a:fontRef idx="minor">
+            <a:schemeClr val="lt1"/>
+          </a:fontRef>
+        </p:style>
+        <p:txBody>
+          <a:bodyPr rtlCol="0" anchor="ctr"/>
+          <a:lstStyle/>
+          <a:p>
+            <a:pPr marL="0" marR="0" lvl="0" indent="0" algn="ctr" defTabSz="457200" rtl="0" eaLnBrk="1" fontAlgn="auto" latinLnBrk="0" hangingPunct="1">
+              <a:lnSpc>
+                <a:spcPct val="100000"/>
+              </a:lnSpc>
+              <a:spcBef>
+                <a:spcPts val="0"/>
+              </a:spcBef>
+              <a:spcAft>
+                <a:spcPts val="0"/>
+              </a:spcAft>
+              <a:buClrTx/>
+              <a:buSzTx/>
+              <a:buFontTx/>
+              <a:buNone/>
+              <a:tabLst/>
+              <a:defRPr/>
+            </a:pPr>
+            <a:r>
+              <a:rPr kumimoji="0" lang="en-GB" sz="1200" b="0" i="0" u="none" strike="noStrike" kern="1200" cap="none" spc="0" normalizeH="0" baseline="0" noProof="0" dirty="0">
+                <a:ln>
+                  <a:noFill/>
+                </a:ln>
+                <a:solidFill>
+                  <a:srgbClr val="FFFFFF"/>
+                </a:solidFill>
+                <a:effectLst/>
+                <a:uLnTx/>
+                <a:uFillTx/>
+                <a:latin typeface="Arial"/>
+                <a:ea typeface="+mn-ea"/>
+                <a:cs typeface="+mn-cs"/>
+              </a:rPr>
+              <a:t>test title</a:t>
+            </a:r>
+            <a:endParaRPr kumimoji="0" lang="en-GB" sz="1200" b="1" i="0" u="none" strike="noStrike" kern="1200" cap="none" spc="0" normalizeH="0" baseline="0" noProof="0" dirty="0">
+              <a:ln>
+                <a:noFill/>
+              </a:ln>
+              <a:solidFill>
+                <a:srgbClr val="FFFFFF"/>
+              </a:solidFill>
+              <a:effectLst/>
+              <a:uLnTx/>
+              <a:uFillTx/>
+              <a:latin typeface="Arial"/>
+              <a:ea typeface="+mn-ea"/>
+              <a:cs typeface="+mn-cs"/>
+            </a:endParaRPr>
+          </a:p>
+        </p:txBody>
+      </p:sp>
+    </p:spTree>
+    <p:extLst>
+      <p:ext uri="{BB962C8B-B14F-4D97-AF65-F5344CB8AC3E}">
+        <p14:creationId xmlns:p14="http://schemas.microsoft.com/office/powerpoint/2010/main" val="1244927296"/>
+      </p:ext>
+    </p:extLst>
+  </p:cSld>
+  <p:clrMapOvr>
+    <a:masterClrMapping/>
+  </p:clrMapOvr>
+  <p:transition/>
+  <p:extLst>
+    <p:ext uri="{6950BFC3-D8DA-4A85-94F7-54DA5524770B}">
+      <p188:commentRel xmlns:p188="http://schemas.microsoft.com/office/powerpoint/2018/8/main" r:id="rId2"/>
+    </p:ext>
+  </p:extLst>
+</p:sld>
+</file>
+
+<file path=ppt/slides/slide5.xml><?xml version="1.0" encoding="utf-8"?>
+<p:sld xmlns:a="http://schemas.openxmlformats.org/drawingml/2006/main" xmlns:r="http://schemas.openxmlformats.org/officeDocument/2006/relationships" xmlns:p="http://schemas.openxmlformats.org/presentationml/2006/main">
+  <p:cSld>
+    <p:spTree>
+      <p:nvGrpSpPr>
+        <p:cNvPr id="1" name=""/>
+        <p:cNvGrpSpPr/>
+        <p:nvPr/>
+      </p:nvGrpSpPr>
+      <p:grpSpPr>
+        <a:xfrm>
+          <a:off x="0" y="0"/>
+          <a:ext cx="0" cy="0"/>
+          <a:chOff x="0" y="0"/>
+          <a:chExt cx="0" cy="0"/>
+        </a:xfrm>
+      </p:grpSpPr>
+      <p:sp>
+        <p:nvSpPr>
+          <p:cNvPr id="5" name="Text Placeholder 4">
+            <a:extLst>
+              <a:ext uri="{FF2B5EF4-FFF2-40B4-BE49-F238E27FC236}">
+                <a16:creationId xmlns:a16="http://schemas.microsoft.com/office/drawing/2014/main" id="{8058E7F8-A0D7-4821-808E-5C3FFD0C2942}"/>
+              </a:ext>
+            </a:extLst>
+          </p:cNvPr>
+          <p:cNvSpPr>
+            <a:spLocks noGrp="1"/>
+          </p:cNvSpPr>
+          <p:nvPr>
+            <p:ph type="body" sz="quarter" idx="10"/>
+          </p:nvPr>
+        </p:nvSpPr>
+        <p:spPr/>
+        <p:txBody>
+          <a:bodyPr/>
+          <a:lstStyle/>
+          <a:p>
+            <a:endParaRPr lang="en-GB"/>
+          </a:p>
+        </p:txBody>
+      </p:sp>
+      <p:sp>
+        <p:nvSpPr>
+          <p:cNvPr id="4" name="Text Placeholder 3"/>
+          <p:cNvSpPr>
+            <a:spLocks noGrp="1"/>
+          </p:cNvSpPr>
+          <p:nvPr>
+            <p:ph type="body" sz="quarter" idx="11"/>
+          </p:nvPr>
+        </p:nvSpPr>
+        <p:spPr>
+          <a:xfrm>
+            <a:off x="250825" y="1736725"/>
+            <a:ext cx="8642350" cy="4645026"/>
+          </a:xfrm>
+        </p:spPr>
+        <p:txBody>
+          <a:bodyPr/>
+          <a:lstStyle/>
+          <a:p>
+            <a:pPr marL="457200" indent="-457200">
+              <a:buFont typeface="Arial" panose="020B0604020202020204" pitchFamily="34" charset="0"/>
+              <a:buChar char="•"/>
+            </a:pPr>
+            <a:r>
+              <a:rPr dirty="0"/>
+              <a:t>Test 1</a:t>
+            </a:r>
+          </a:p>
+          <a:p>
+            <a:pPr marL="457200" indent="-457200">
+              <a:buFont typeface="Arial" panose="020B0604020202020204" pitchFamily="34" charset="0"/>
+              <a:buChar char="•"/>
+            </a:pPr>
+            <a:r>
+              <a:rPr dirty="0"/>
+              <a:t>Test 2</a:t>
+            </a:r>
+          </a:p>
+        </p:txBody>
+      </p:sp>
+      <p:pic>
+        <p:nvPicPr>
+          <p:cNvPr id="1" name="Picture 1" descr="Picture 1"/>
+          <p:cNvPicPr>
+            <a:picLocks noChangeAspect="1" noChangeArrowheads="1"/>
+          </p:cNvPicPr>
+          <p:nvPr/>
+        </p:nvPicPr>
+        <p:blipFill>
+          <a:blip r:embed="rId2" cstate="print"/>
+          <a:srcRect/>
+          <a:stretch>
+            <a:fillRect/>
+          </a:stretch>
+        </p:blipFill>
+        <p:spPr bwMode="auto">
+          <a:xfrm>
+            <a:off x="1016000" y="2451100"/>
+            <a:ext cx="6883400" cy="3644900"/>
+          </a:xfrm>
+          <a:prstGeom prst="rect">
+            <a:avLst/>
+          </a:prstGeom>
+          <a:noFill/>
+        </p:spPr>
+      </p:pic>
+      <p:sp>
+        <p:nvSpPr>
+          <p:cNvPr id="8" name="Title 7">
+            <a:extLst>
+              <a:ext uri="{FF2B5EF4-FFF2-40B4-BE49-F238E27FC236}">
+                <a16:creationId xmlns:a16="http://schemas.microsoft.com/office/drawing/2014/main" id="{F81155E6-8BF1-458B-B680-D4A2EBFAC2B5}"/>
+              </a:ext>
+            </a:extLst>
+          </p:cNvPr>
+          <p:cNvSpPr>
+            <a:spLocks noGrp="1"/>
+          </p:cNvSpPr>
+          <p:nvPr>
+            <p:ph type="title"/>
+          </p:nvPr>
+        </p:nvSpPr>
+        <p:spPr>
+          <a:xfrm>
+            <a:off x="250828" y="727200"/>
+            <a:ext cx="8642348" cy="886397"/>
+          </a:xfrm>
+        </p:spPr>
+        <p:txBody>
+          <a:bodyPr/>
+          <a:lstStyle/>
+          <a:p>
+            <a:r>
+              <a:rPr lang="en-GB" dirty="0"/>
+              <a:t>A very long title to test breaking over two lines works correctly</a:t>
+            </a:r>
+          </a:p>
+        </p:txBody>
+      </p:sp>
+    </p:spTree>
+    <p:extLst>
+      <p:ext uri="{BB962C8B-B14F-4D97-AF65-F5344CB8AC3E}">
+        <p14:creationId xmlns:p14="http://schemas.microsoft.com/office/powerpoint/2010/main" val="3054531529"/>
+      </p:ext>
+    </p:extLst>
+  </p:cSld>
+  <p:clrMapOvr>
+    <a:masterClrMapping/>
+  </p:clrMapOvr>
+</p:sld>
+</file>
+
+<file path=ppt/slides/slide6.xml><?xml version="1.0" encoding="utf-8"?>
 <p:sld xmlns:a="http://schemas.openxmlformats.org/drawingml/2006/main" xmlns:r="http://schemas.openxmlformats.org/officeDocument/2006/relationships" xmlns:p="http://schemas.openxmlformats.org/presentationml/2006/main">
   <p:cSld>
     <p:spTree>
@@ -26444,7 +28571,7 @@
 </p:sld>
 </file>
 
-<file path=ppt/slides/slide4.xml><?xml version="1.0" encoding="utf-8"?>
+<file path=ppt/slides/slide7.xml><?xml version="1.0" encoding="utf-8"?>
 <p:sld xmlns:a="http://schemas.openxmlformats.org/drawingml/2006/main" xmlns:r="http://schemas.openxmlformats.org/officeDocument/2006/relationships" xmlns:p="http://schemas.openxmlformats.org/presentationml/2006/main">
   <p:cSld>
     <p:spTree>
@@ -26803,7 +28930,366 @@
 </p:sld>
 </file>
 
-<file path=ppt/slides/slide5.xml><?xml version="1.0" encoding="utf-8"?>
+<file path=ppt/slides/slide8.xml><?xml version="1.0" encoding="utf-8"?>
+<p:sld xmlns:a="http://schemas.openxmlformats.org/drawingml/2006/main" xmlns:r="http://schemas.openxmlformats.org/officeDocument/2006/relationships" xmlns:p="http://schemas.openxmlformats.org/presentationml/2006/main">
+  <p:cSld>
+    <p:spTree>
+      <p:nvGrpSpPr>
+        <p:cNvPr id="1" name=""/>
+        <p:cNvGrpSpPr/>
+        <p:nvPr/>
+      </p:nvGrpSpPr>
+      <p:grpSpPr>
+        <a:xfrm>
+          <a:off x="0" y="0"/>
+          <a:ext cx="0" cy="0"/>
+          <a:chOff x="0" y="0"/>
+          <a:chExt cx="0" cy="0"/>
+        </a:xfrm>
+      </p:grpSpPr>
+      <p:sp>
+        <p:nvSpPr>
+          <p:cNvPr id="24" name="Text Placeholder 23">
+            <a:extLst>
+              <a:ext uri="{FF2B5EF4-FFF2-40B4-BE49-F238E27FC236}">
+                <a16:creationId xmlns:a16="http://schemas.microsoft.com/office/drawing/2014/main" id="{792E7250-EAF1-4D42-A515-5751E81D9862}"/>
+              </a:ext>
+            </a:extLst>
+          </p:cNvPr>
+          <p:cNvSpPr>
+            <a:spLocks noGrp="1"/>
+          </p:cNvSpPr>
+          <p:nvPr>
+            <p:ph type="body" sz="quarter" idx="33"/>
+          </p:nvPr>
+        </p:nvSpPr>
+        <p:spPr/>
+        <p:txBody>
+          <a:bodyPr/>
+          <a:lstStyle/>
+          <a:p>
+            <a:r>
+              <a:rPr lang="en-GB" dirty="0"/>
+              <a:t>5 years ago</a:t>
+            </a:r>
+          </a:p>
+        </p:txBody>
+      </p:sp>
+      <p:sp>
+        <p:nvSpPr>
+          <p:cNvPr id="25" name="Text Placeholder 24">
+            <a:extLst>
+              <a:ext uri="{FF2B5EF4-FFF2-40B4-BE49-F238E27FC236}">
+                <a16:creationId xmlns:a16="http://schemas.microsoft.com/office/drawing/2014/main" id="{A97B7BE9-D6FF-4D3F-9146-B39043D6D393}"/>
+              </a:ext>
+            </a:extLst>
+          </p:cNvPr>
+          <p:cNvSpPr>
+            <a:spLocks noGrp="1"/>
+          </p:cNvSpPr>
+          <p:nvPr>
+            <p:ph type="body" sz="quarter" idx="34"/>
+          </p:nvPr>
+        </p:nvSpPr>
+        <p:spPr/>
+        <p:txBody>
+          <a:bodyPr/>
+          <a:lstStyle/>
+          <a:p>
+            <a:r>
+              <a:rPr lang="en-GB" dirty="0"/>
+              <a:t>Now</a:t>
+            </a:r>
+          </a:p>
+        </p:txBody>
+      </p:sp>
+      <p:sp>
+        <p:nvSpPr>
+          <p:cNvPr id="26" name="Text Placeholder 25">
+            <a:extLst>
+              <a:ext uri="{FF2B5EF4-FFF2-40B4-BE49-F238E27FC236}">
+                <a16:creationId xmlns:a16="http://schemas.microsoft.com/office/drawing/2014/main" id="{ECA90FCF-6B85-4635-A97C-7F77860E7455}"/>
+              </a:ext>
+            </a:extLst>
+          </p:cNvPr>
+          <p:cNvSpPr>
+            <a:spLocks noGrp="1"/>
+          </p:cNvSpPr>
+          <p:nvPr>
+            <p:ph type="body" sz="quarter" idx="35"/>
+          </p:nvPr>
+        </p:nvSpPr>
+        <p:spPr/>
+        <p:txBody>
+          <a:bodyPr/>
+          <a:lstStyle/>
+          <a:p>
+            <a:r>
+              <a:rPr lang="en-GB" dirty="0"/>
+              <a:t>in 5 years</a:t>
+            </a:r>
+          </a:p>
+        </p:txBody>
+      </p:sp>
+      <p:sp>
+        <p:nvSpPr>
+          <p:cNvPr id="23" name="Text Placeholder 22">
+            <a:extLst>
+              <a:ext uri="{FF2B5EF4-FFF2-40B4-BE49-F238E27FC236}">
+                <a16:creationId xmlns:a16="http://schemas.microsoft.com/office/drawing/2014/main" id="{DC891246-AA8A-4D0E-82B4-8B5CE689E179}"/>
+              </a:ext>
+            </a:extLst>
+          </p:cNvPr>
+          <p:cNvSpPr>
+            <a:spLocks noGrp="1"/>
+          </p:cNvSpPr>
+          <p:nvPr>
+            <p:ph type="body" sz="quarter" idx="10"/>
+          </p:nvPr>
+        </p:nvSpPr>
+        <p:spPr/>
+        <p:txBody>
+          <a:bodyPr/>
+          <a:lstStyle/>
+          <a:p>
+            <a:endParaRPr lang="en-GB"/>
+          </a:p>
+        </p:txBody>
+      </p:sp>
+      <p:sp>
+        <p:nvSpPr>
+          <p:cNvPr id="3" name="Title 2"/>
+          <p:cNvSpPr>
+            <a:spLocks noGrp="1"/>
+          </p:cNvSpPr>
+          <p:nvPr>
+            <p:ph type="title"/>
+          </p:nvPr>
+        </p:nvSpPr>
+        <p:spPr/>
+        <p:txBody>
+          <a:bodyPr/>
+          <a:lstStyle/>
+          <a:p>
+            <a:r>
+              <a:rPr lang="en-GB" dirty="0"/>
+              <a:t>What will happen next 2</a:t>
+            </a:r>
+          </a:p>
+        </p:txBody>
+      </p:sp>
+      <p:sp>
+        <p:nvSpPr>
+          <p:cNvPr id="8" name="6"/>
+          <p:cNvSpPr>
+            <a:spLocks noGrp="1"/>
+          </p:cNvSpPr>
+          <p:nvPr>
+            <p:ph type="body" sz="quarter" idx="24"/>
+          </p:nvPr>
+        </p:nvSpPr>
+        <p:spPr/>
+        <p:txBody>
+          <a:bodyPr/>
+          <a:lstStyle/>
+          <a:p>
+            <a:r>
+              <a:rPr lang="en-GB" dirty="0"/>
+              <a:t>Social media platforms and review sites extend the range of products and services that consumers can publicly review. In 2012, 340 million tweets were posted per day.</a:t>
+            </a:r>
+          </a:p>
+        </p:txBody>
+      </p:sp>
+      <p:sp>
+        <p:nvSpPr>
+          <p:cNvPr id="9" name="Text Placeholder Text Placeholder 8"/>
+          <p:cNvSpPr>
+            <a:spLocks noGrp="1"/>
+          </p:cNvSpPr>
+          <p:nvPr>
+            <p:ph type="body" sz="quarter" idx="25"/>
+          </p:nvPr>
+        </p:nvSpPr>
+        <p:spPr/>
+        <p:txBody>
+          <a:bodyPr/>
+          <a:lstStyle/>
+          <a:p>
+            <a:r>
+              <a:rPr lang="en-GB" dirty="0"/>
+              <a:t>Brand interaction with online customer complaints is limited, with customer service efforts focused on in-store feedback and complaints.</a:t>
+            </a:r>
+          </a:p>
+        </p:txBody>
+      </p:sp>
+      <p:sp>
+        <p:nvSpPr>
+          <p:cNvPr id="10" name="Text Placeholder 9"/>
+          <p:cNvSpPr>
+            <a:spLocks noGrp="1"/>
+          </p:cNvSpPr>
+          <p:nvPr>
+            <p:ph type="body" sz="quarter" idx="26"/>
+          </p:nvPr>
+        </p:nvSpPr>
+        <p:spPr/>
+        <p:txBody>
+          <a:bodyPr/>
+          <a:lstStyle/>
+          <a:p>
+            <a:r>
+              <a:rPr lang="en-GB" dirty="0"/>
+              <a:t/>
+            </a:r>
+          </a:p>
+        </p:txBody>
+      </p:sp>
+      <p:sp>
+        <p:nvSpPr>
+          <p:cNvPr id="11" name="9"/>
+          <p:cNvSpPr>
+            <a:spLocks noGrp="1"/>
+          </p:cNvSpPr>
+          <p:nvPr>
+            <p:ph type="body" sz="quarter" idx="27"/>
+          </p:nvPr>
+        </p:nvSpPr>
+        <p:spPr/>
+        <p:txBody>
+          <a:bodyPr/>
+          <a:lstStyle/>
+          <a:p>
+            <a:r>
+              <a:rPr lang="en-GB" dirty="0"/>
+              <a:t>High smartphone ownership allows customers to quickly write or read reviews on the go. Semi-expert consumer voices have arisen in most sectors, whose opinions are given extra weight.</a:t>
+            </a:r>
+          </a:p>
+        </p:txBody>
+      </p:sp>
+      <p:sp>
+        <p:nvSpPr>
+          <p:cNvPr id="12" name="Text Placeholder Text Placeholder 11"/>
+          <p:cNvSpPr>
+            <a:spLocks noGrp="1"/>
+          </p:cNvSpPr>
+          <p:nvPr>
+            <p:ph type="body" sz="quarter" idx="28"/>
+          </p:nvPr>
+        </p:nvSpPr>
+        <p:spPr/>
+        <p:txBody>
+          <a:bodyPr/>
+          <a:lstStyle/>
+          <a:p>
+            <a:r>
+              <a:rPr lang="en-GB" dirty="0"/>
+              <a:t>Brands find new ways of interacting with customers across a range of social media channels, addressing and responding to concerns, complaints and compliments.</a:t>
+            </a:r>
+          </a:p>
+        </p:txBody>
+      </p:sp>
+      <p:sp>
+        <p:nvSpPr>
+          <p:cNvPr id="13" name="Text Placeholder 12"/>
+          <p:cNvSpPr>
+            <a:spLocks noGrp="1"/>
+          </p:cNvSpPr>
+          <p:nvPr>
+            <p:ph type="body" sz="quarter" idx="29"/>
+          </p:nvPr>
+        </p:nvSpPr>
+        <p:spPr/>
+        <p:txBody>
+          <a:bodyPr/>
+          <a:lstStyle/>
+          <a:p>
+            <a:r>
+              <a:rPr lang="en-GB" dirty="0"/>
+              <a:t/>
+            </a:r>
+          </a:p>
+        </p:txBody>
+      </p:sp>
+      <p:sp>
+        <p:nvSpPr>
+          <p:cNvPr id="14" name="12"/>
+          <p:cNvSpPr>
+            <a:spLocks noGrp="1"/>
+          </p:cNvSpPr>
+          <p:nvPr>
+            <p:ph type="body" sz="quarter" idx="30"/>
+          </p:nvPr>
+        </p:nvSpPr>
+        <p:spPr/>
+        <p:txBody>
+          <a:bodyPr/>
+          <a:lstStyle/>
+          <a:p>
+            <a:r>
+              <a:rPr lang="en-GB" dirty="0"/>
+              <a:t>An increase in attempts to verify identifies of reviewers in order to rate the trustworthiness of their voices. Fewer sites will allow anonymous reviews to be posted.</a:t>
+            </a:r>
+          </a:p>
+        </p:txBody>
+      </p:sp>
+      <p:sp>
+        <p:nvSpPr>
+          <p:cNvPr id="15" name="Text Placeholder Text Placeholder 14"/>
+          <p:cNvSpPr>
+            <a:spLocks noGrp="1"/>
+          </p:cNvSpPr>
+          <p:nvPr>
+            <p:ph type="body" sz="quarter" idx="31"/>
+          </p:nvPr>
+        </p:nvSpPr>
+        <p:spPr/>
+        <p:txBody>
+          <a:bodyPr/>
+          <a:lstStyle/>
+          <a:p>
+            <a:r>
+              <a:rPr lang="en-GB" dirty="0"/>
+              <a:t>Inviting and engaging consumers to react, review and critique in advance of product or service launches becomes more common for brands.</a:t>
+            </a:r>
+          </a:p>
+        </p:txBody>
+      </p:sp>
+      <p:sp>
+        <p:nvSpPr>
+          <p:cNvPr id="16" name="Text Placeholder 15"/>
+          <p:cNvSpPr>
+            <a:spLocks noGrp="1"/>
+          </p:cNvSpPr>
+          <p:nvPr>
+            <p:ph type="body" sz="quarter" idx="32"/>
+          </p:nvPr>
+        </p:nvSpPr>
+        <p:spPr/>
+        <p:txBody>
+          <a:bodyPr/>
+          <a:lstStyle/>
+          <a:p>
+            <a:r>
+              <a:rPr lang="en-GB" dirty="0"/>
+              <a:t/>
+            </a:r>
+          </a:p>
+        </p:txBody>
+      </p:sp>
+    </p:spTree>
+    <p:extLst>
+      <p:ext uri="{BB962C8B-B14F-4D97-AF65-F5344CB8AC3E}">
+        <p14:creationId xmlns:p14="http://schemas.microsoft.com/office/powerpoint/2010/main" val="607448638"/>
+      </p:ext>
+    </p:extLst>
+  </p:cSld>
+  <p:clrMapOvr>
+    <a:masterClrMapping/>
+  </p:clrMapOvr>
+</p:sld>
+</file>
+
+<file path=ppt/slides/slide9.xml><?xml version="1.0" encoding="utf-8"?>
 <p:sld xmlns:a="http://schemas.openxmlformats.org/drawingml/2006/main" xmlns:r="http://schemas.openxmlformats.org/officeDocument/2006/relationships" xmlns:p="http://schemas.openxmlformats.org/presentationml/2006/main">
   <p:cSld>
     <p:spTree>
@@ -26912,78 +29398,6 @@
     <a:masterClrMapping/>
   </p:clrMapOvr>
   <p:transition/>
-</p:sld>
-</file>
-
-<file path=ppt/slides/slide6.xml><?xml version="1.0" encoding="utf-8"?>
-<p:sld xmlns:a="http://schemas.openxmlformats.org/drawingml/2006/main" xmlns:r="http://schemas.openxmlformats.org/officeDocument/2006/relationships" xmlns:p="http://schemas.openxmlformats.org/presentationml/2006/main">
-  <p:cSld>
-    <p:spTree>
-      <p:nvGrpSpPr>
-        <p:cNvPr id="1" name=""/>
-        <p:cNvGrpSpPr/>
-        <p:nvPr/>
-      </p:nvGrpSpPr>
-      <p:grpSpPr>
-        <a:xfrm>
-          <a:off x="0" y="0"/>
-          <a:ext cx="0" cy="0"/>
-          <a:chOff x="0" y="0"/>
-          <a:chExt cx="0" cy="0"/>
-        </a:xfrm>
-      </p:grpSpPr>
-      <p:sp>
-        <p:nvSpPr>
-          <p:cNvPr id="4" name="Text Placeholder 3">
-            <a:extLst>
-              <a:ext uri="{FF2B5EF4-FFF2-40B4-BE49-F238E27FC236}">
-                <a16:creationId xmlns:a16="http://schemas.microsoft.com/office/drawing/2014/main" id="{9085BD27-5E0B-4AF1-82E4-2FCE3C656DF8}"/>
-              </a:ext>
-            </a:extLst>
-          </p:cNvPr>
-          <p:cNvSpPr>
-            <a:spLocks noGrp="1"/>
-          </p:cNvSpPr>
-          <p:nvPr>
-            <p:ph type="body" sz="quarter" idx="10"/>
-          </p:nvPr>
-        </p:nvSpPr>
-        <p:spPr>
-          <a:xfrm>
-            <a:off x="250825" y="5270691"/>
-            <a:ext cx="8642350" cy="276999"/>
-          </a:xfrm>
-        </p:spPr>
-        <p:txBody>
-          <a:bodyPr/>
-          <a:lstStyle/>
-          <a:p>
-            <a:r>
-              <a:rPr lang="en-GB" dirty="0">
-                <a:hlinkClick r:id="rId2">
-                  <a:extLst>
-                    <a:ext uri="{A12FA001-AC4F-418D-AE19-62706E023703}">
-                      <ahyp:hlinkClr xmlns:ahyp="http://schemas.microsoft.com/office/drawing/2018/hyperlinkcolor" val="tx"/>
-                    </a:ext>
-                  </a:extLst>
-                </a:hlinkClick>
-              </a:rPr>
-              <a:t>collision-help@foresightfactory.co</a:t>
-            </a:r>
-            <a:endParaRPr lang="en-GB" dirty="0"/>
-          </a:p>
-        </p:txBody>
-      </p:sp>
-    </p:spTree>
-    <p:extLst>
-      <p:ext uri="{BB962C8B-B14F-4D97-AF65-F5344CB8AC3E}">
-        <p14:creationId xmlns:p14="http://schemas.microsoft.com/office/powerpoint/2010/main" val="3566619164"/>
-      </p:ext>
-    </p:extLst>
-  </p:cSld>
-  <p:clrMapOvr>
-    <a:masterClrMapping/>
-  </p:clrMapOvr>
 </p:sld>
 </file>
 

</xml_diff>

<commit_message>
tidy up and include latest pptx output
</commit_message>
<xml_diff>
--- a/samples/pptx/test-output.pptx
+++ b/samples/pptx/test-output.pptx
@@ -125,122 +125,6 @@
     </p:ext>
   </p:extLst>
 </p:presentation>
-</file>
-
-<file path=ppt/comments/modernComment_145_C73B0D4E.xml><?xml version="1.0" encoding="utf-8"?>
-<p188:cmLst xmlns:a="http://schemas.openxmlformats.org/drawingml/2006/main" xmlns:r="http://schemas.openxmlformats.org/officeDocument/2006/relationships" xmlns:p188="http://schemas.microsoft.com/office/powerpoint/2018/8/main">
-  <p188:cm id="{8E69C85A-BB49-47B8-94A9-DFEC57DBBD31}" authorId="{1BA2220E-EAF1-36E2-996E-E941808F1272}" created="2022-07-07T12:59:26.574">
-    <ac:deMkLst xmlns:ac="http://schemas.microsoft.com/office/drawing/2013/main/command">
-      <pc:docMk xmlns:pc="http://schemas.microsoft.com/office/powerpoint/2013/main/command"/>
-      <pc:sldMk xmlns:pc="http://schemas.microsoft.com/office/powerpoint/2013/main/command" cId="3342536014" sldId="325"/>
-      <ac:spMk id="40" creationId="{1F63B656-ED1F-A95B-D736-D0F4C45A8B98}"/>
-    </ac:deMkLst>
-    <p188:txBody>
-      <a:bodyPr/>
-      <a:lstStyle/>
-      <a:p>
-        <a:r>
-          <a:rPr lang="en-GB"/>
-          <a:t>cover image tbc</a:t>
-        </a:r>
-      </a:p>
-    </p188:txBody>
-  </p188:cm>
-  <p188:cm id="{A76B94FD-9AE5-4192-BFFB-D585490A37B9}" authorId="{1BA2220E-EAF1-36E2-996E-E941808F1272}" created="2022-07-07T13:21:23.898">
-    <pc:sldMkLst xmlns:pc="http://schemas.microsoft.com/office/powerpoint/2013/main/command">
-      <pc:docMk/>
-      <pc:sldMk cId="3342536014" sldId="325"/>
-    </pc:sldMkLst>
-    <p188:pos x="4486275" y="4025900"/>
-    <p188:txBody>
-      <a:bodyPr/>
-      <a:lstStyle/>
-      <a:p>
-        <a:r>
-          <a:rPr lang="en-GB"/>
-          <a:t>text taken from question, audience, market specified</a:t>
-        </a:r>
-      </a:p>
-    </p188:txBody>
-  </p188:cm>
-</p188:cmLst>
-</file>
-
-<file path=ppt/comments/modernComment_AD0_4A341540.xml><?xml version="1.0" encoding="utf-8"?>
-<p188:cmLst xmlns:a="http://schemas.openxmlformats.org/drawingml/2006/main" xmlns:r="http://schemas.openxmlformats.org/officeDocument/2006/relationships" xmlns:p188="http://schemas.microsoft.com/office/powerpoint/2018/8/main">
-  <p188:cm id="{7B67954C-DB90-4155-9FC1-96260E4EEBB1}" authorId="{1BA2220E-EAF1-36E2-996E-E941808F1272}" created="2022-07-07T13:41:19.759">
-    <pc:sldMkLst xmlns:pc="http://schemas.microsoft.com/office/powerpoint/2013/main/command">
-      <pc:docMk/>
-      <pc:sldMk cId="1244927296" sldId="2768"/>
-    </pc:sldMkLst>
-    <p188:txBody>
-      <a:bodyPr/>
-      <a:lstStyle/>
-      <a:p>
-        <a:r>
-          <a:rPr lang="en-GB"/>
-          <a:t>As above, to illustrate with more Trends</a:t>
-        </a:r>
-      </a:p>
-    </p188:txBody>
-  </p188:cm>
-</p188:cmLst>
-</file>
-
-<file path=ppt/comments/modernComment_AD1_23A2652.xml><?xml version="1.0" encoding="utf-8"?>
-<p188:cmLst xmlns:a="http://schemas.openxmlformats.org/drawingml/2006/main" xmlns:r="http://schemas.openxmlformats.org/officeDocument/2006/relationships" xmlns:p188="http://schemas.microsoft.com/office/powerpoint/2018/8/main">
-  <p188:cm id="{21016D25-BAB3-4C3B-8383-CCF2E2B02BF5}" authorId="{1BA2220E-EAF1-36E2-996E-E941808F1272}" created="2022-07-07T13:40:36.171">
-    <ac:deMkLst xmlns:ac="http://schemas.microsoft.com/office/drawing/2013/main/command">
-      <pc:docMk xmlns:pc="http://schemas.microsoft.com/office/powerpoint/2013/main/command"/>
-      <pc:sldMk xmlns:pc="http://schemas.microsoft.com/office/powerpoint/2013/main/command" cId="37365330" sldId="2769"/>
-      <ac:spMk id="5" creationId="{5A2A17F5-BDB6-3277-82F6-DE5BCCE429BF}"/>
-    </ac:deMkLst>
-    <p188:txBody>
-      <a:bodyPr/>
-      <a:lstStyle/>
-      <a:p>
-        <a:r>
-          <a:rPr lang="en-GB"/>
-          <a:t>additional slides can be introduced as needed, same styling, numbers continue to run as high as required</a:t>
-        </a:r>
-      </a:p>
-    </p188:txBody>
-  </p188:cm>
-  <p188:cm id="{B13BE74A-B089-4C78-901B-DCC50A7DF46E}" authorId="{1BA2220E-EAF1-36E2-996E-E941808F1272}" created="2022-07-07T13:40:54.374">
-    <ac:deMkLst xmlns:ac="http://schemas.microsoft.com/office/drawing/2013/main/command">
-      <pc:docMk xmlns:pc="http://schemas.microsoft.com/office/powerpoint/2013/main/command"/>
-      <pc:sldMk xmlns:pc="http://schemas.microsoft.com/office/powerpoint/2013/main/command" cId="37365330" sldId="2769"/>
-      <ac:spMk id="5" creationId="{5A2A17F5-BDB6-3277-82F6-DE5BCCE429BF}"/>
-    </ac:deMkLst>
-    <p188:txBody>
-      <a:bodyPr/>
-      <a:lstStyle/>
-      <a:p>
-        <a:r>
-          <a:rPr lang="en-GB"/>
-          <a:t>Numbers should not be bold, and should be in standard dark purple (not bright)</a:t>
-        </a:r>
-      </a:p>
-    </p188:txBody>
-  </p188:cm>
-  <p188:cm id="{CC0086BA-4831-482B-8056-C92A4B3C20CA}" authorId="{1BA2220E-EAF1-36E2-996E-E941808F1272}" created="2022-07-07T14:05:10.144">
-    <pc:sldMkLst xmlns:pc="http://schemas.microsoft.com/office/powerpoint/2013/main/command">
-      <pc:docMk/>
-      <pc:sldMk cId="37365330" sldId="2769"/>
-    </pc:sldMkLst>
-    <p188:pos x="463550" y="1374775"/>
-    <p188:txBody>
-      <a:bodyPr/>
-      <a:lstStyle/>
-      <a:p>
-        <a:r>
-          <a:rPr lang="en-GB"/>
-          <a:t> hyperlink to the trend page on main Collision site</a:t>
-        </a:r>
-      </a:p>
-    </p188:txBody>
-  </p188:cm>
-</p188:cmLst>
 </file>
 
 <file path=ppt/handoutMasters/handoutMaster1.xml><?xml version="1.0" encoding="utf-8"?>

</xml_diff>

<commit_message>
Update the master template
 - Supporting the new trend list summary there were issues with
 conflicts in the slides and slidemasters. This commit introduces a new
 templated pptx that fixes these issues combining the new trendlists and
 covers slides with the older slide layouts.
</commit_message>
<xml_diff>
--- a/samples/pptx/test-output.pptx
+++ b/samples/pptx/test-output.pptx
@@ -16,8 +16,6 @@
     <p:sldId id="263" r:id="rId8"/>
     <p:sldId id="264" r:id="rId9"/>
     <p:sldId id="265" r:id="rId10"/>
-    <p:sldId id="266" r:id="rId11"/>
-    <p:sldId id="267" r:id="rId12"/>
   </p:sldIdLst>
   <p:sldSz cx="9144000" cy="6858000" type="screen4x3"/>
   <p:notesSz cx="6858000" cy="9144000"/>
@@ -221,7 +219,7 @@
           <a:p>
             <a:fld id="{8F897744-BA97-4D45-8EDD-3C10398B4E6F}" type="datetimeFigureOut">
               <a:rPr lang="en-GB" smtClean="0"/>
-              <a:t>17/11/2020</a:t>
+              <a:t>05/09/2022</a:t>
             </a:fld>
             <a:endParaRPr lang="en-GB"/>
           </a:p>
@@ -399,7 +397,7 @@
             <a:fld id="{F26CFFA1-E31C-4403-BF25-43564C874A0C}" type="datetimeFigureOut">
               <a:rPr lang="en-US" smtClean="0"/>
               <a:pPr/>
-              <a:t>11/17/2020</a:t>
+              <a:t>9/5/22</a:t>
             </a:fld>
             <a:endParaRPr lang="en-US"/>
           </a:p>
@@ -9837,7 +9835,160 @@
 </file>
 
 <file path=ppt/slideLayouts/slideLayout10.xml><?xml version="1.0" encoding="utf-8"?>
-<p:sldLayout xmlns:a="http://schemas.openxmlformats.org/drawingml/2006/main" xmlns:r="http://schemas.openxmlformats.org/officeDocument/2006/relationships" xmlns:p="http://schemas.openxmlformats.org/presentationml/2006/main" userDrawn="1">
+<p:sldLayout xmlns:a="http://schemas.openxmlformats.org/drawingml/2006/main" xmlns:r="http://schemas.openxmlformats.org/officeDocument/2006/relationships" xmlns:p="http://schemas.openxmlformats.org/presentationml/2006/main" type="tx">
+  <p:cSld>
+    <p:spTree>
+      <p:nvGrpSpPr>
+        <p:cNvPr id="1" name=""/>
+        <p:cNvGrpSpPr/>
+        <p:nvPr/>
+      </p:nvGrpSpPr>
+      <p:grpSpPr>
+        <a:xfrm>
+          <a:off x="0" y="0"/>
+          <a:ext cx="0" cy="0"/>
+          <a:chOff x="0" y="0"/>
+          <a:chExt cx="0" cy="0"/>
+        </a:xfrm>
+      </p:grpSpPr>
+      <p:sp>
+        <p:nvSpPr>
+          <p:cNvPr id="2" name="Title 1">
+            <a:extLst>
+              <a:ext uri="{FF2B5EF4-FFF2-40B4-BE49-F238E27FC236}">
+                <a16:creationId xmlns:a16="http://schemas.microsoft.com/office/drawing/2014/main" id="{B7D49BA9-9B99-2606-618E-5CE9AECB1945}"/>
+              </a:ext>
+            </a:extLst>
+          </p:cNvPr>
+          <p:cNvSpPr>
+            <a:spLocks noGrp="1"/>
+          </p:cNvSpPr>
+          <p:nvPr>
+            <p:ph type="title"/>
+          </p:nvPr>
+        </p:nvSpPr>
+        <p:spPr>
+          <a:xfrm>
+            <a:off x="628650" y="365125"/>
+            <a:ext cx="7886700" cy="1325563"/>
+          </a:xfrm>
+          <a:prstGeom prst="rect">
+            <a:avLst/>
+          </a:prstGeom>
+        </p:spPr>
+        <p:txBody>
+          <a:bodyPr/>
+          <a:lstStyle/>
+          <a:p>
+            <a:r>
+              <a:rPr lang="en-GB"/>
+              <a:t>Click to edit Master title style</a:t>
+            </a:r>
+            <a:endParaRPr lang="en-US"/>
+          </a:p>
+        </p:txBody>
+      </p:sp>
+      <p:sp>
+        <p:nvSpPr>
+          <p:cNvPr id="3" name="Text Placeholder 2">
+            <a:extLst>
+              <a:ext uri="{FF2B5EF4-FFF2-40B4-BE49-F238E27FC236}">
+                <a16:creationId xmlns:a16="http://schemas.microsoft.com/office/drawing/2014/main" id="{ECEB6B89-D179-332E-042B-7C25C8E8B2AE}"/>
+              </a:ext>
+            </a:extLst>
+          </p:cNvPr>
+          <p:cNvSpPr>
+            <a:spLocks noGrp="1"/>
+          </p:cNvSpPr>
+          <p:nvPr>
+            <p:ph type="body" idx="1"/>
+          </p:nvPr>
+        </p:nvSpPr>
+        <p:spPr>
+          <a:xfrm>
+            <a:off x="628650" y="1825625"/>
+            <a:ext cx="7886700" cy="4351338"/>
+          </a:xfrm>
+          <a:prstGeom prst="rect">
+            <a:avLst/>
+          </a:prstGeom>
+        </p:spPr>
+        <p:txBody>
+          <a:bodyPr/>
+          <a:lstStyle/>
+          <a:p>
+            <a:pPr lvl="0"/>
+            <a:r>
+              <a:rPr lang="en-GB"/>
+              <a:t>Click to edit Master text styles</a:t>
+            </a:r>
+          </a:p>
+          <a:p>
+            <a:pPr lvl="1"/>
+            <a:r>
+              <a:rPr lang="en-GB"/>
+              <a:t>Second level</a:t>
+            </a:r>
+          </a:p>
+          <a:p>
+            <a:pPr lvl="2"/>
+            <a:r>
+              <a:rPr lang="en-GB"/>
+              <a:t>Third level</a:t>
+            </a:r>
+          </a:p>
+          <a:p>
+            <a:pPr lvl="3"/>
+            <a:r>
+              <a:rPr lang="en-GB"/>
+              <a:t>Fourth level</a:t>
+            </a:r>
+          </a:p>
+          <a:p>
+            <a:pPr lvl="4"/>
+            <a:r>
+              <a:rPr lang="en-GB"/>
+              <a:t>Fifth level</a:t>
+            </a:r>
+            <a:endParaRPr lang="en-US"/>
+          </a:p>
+        </p:txBody>
+      </p:sp>
+    </p:spTree>
+  </p:cSld>
+  <p:clrMapOvr>
+    <a:masterClrMapping/>
+  </p:clrMapOvr>
+</p:sldLayout>
+</file>
+
+<file path=ppt/slideLayouts/slideLayout11.xml><?xml version="1.0" encoding="utf-8"?>
+<p:sldLayout xmlns:a="http://schemas.openxmlformats.org/drawingml/2006/main" xmlns:r="http://schemas.openxmlformats.org/officeDocument/2006/relationships" xmlns:p="http://schemas.openxmlformats.org/presentationml/2006/main" type="tx">
+  <p:cSld>
+    <p:spTree>
+      <p:nvGrpSpPr>
+        <p:cNvPr id="1" name=""/>
+        <p:cNvGrpSpPr/>
+        <p:nvPr/>
+      </p:nvGrpSpPr>
+      <p:grpSpPr>
+        <a:xfrm>
+          <a:off x="0" y="0"/>
+          <a:ext cx="0" cy="0"/>
+          <a:chOff x="0" y="0"/>
+          <a:chExt cx="0" cy="0"/>
+        </a:xfrm>
+      </p:grpSpPr>
+    </p:spTree>
+  </p:cSld>
+  <p:clrMapOvr>
+    <a:masterClrMapping/>
+  </p:clrMapOvr>
+</p:sldLayout>
+</file>
+
+<file path=ppt/slideLayouts/slideLayout12.xml><?xml version="1.0" encoding="utf-8"?>
+<p:sldLayout xmlns:a="http://schemas.openxmlformats.org/drawingml/2006/main" xmlns:r="http://schemas.openxmlformats.org/officeDocument/2006/relationships" xmlns:p="http://schemas.openxmlformats.org/presentationml/2006/main" preserve="1" userDrawn="1">
   <p:cSld name="scatterlist">
     <p:spTree>
       <p:nvGrpSpPr>
@@ -10519,7 +10670,7 @@
     </p:spTree>
     <p:extLst>
       <p:ext uri="{BB962C8B-B14F-4D97-AF65-F5344CB8AC3E}">
-        <p14:creationId xmlns:p14="http://schemas.microsoft.com/office/powerpoint/2010/main" val="3487409176"/>
+        <p14:creationId xmlns:p14="http://schemas.microsoft.com/office/powerpoint/2010/main" val="2145279314"/>
       </p:ext>
     </p:extLst>
   </p:cSld>
@@ -26415,11 +26566,14 @@
     <p:sldLayoutId id="2147484064" r:id="rId2"/>
     <p:sldLayoutId id="2147484065" r:id="rId3"/>
     <p:sldLayoutId id="2147484066" r:id="rId4"/>
-    <p:sldLayoutId id="2147484074" r:id="rId5"/>
+    <p:sldLayoutId id="2147484067" r:id="rId5"/>
     <p:sldLayoutId id="2147484068" r:id="rId6"/>
     <p:sldLayoutId id="2147484069" r:id="rId7"/>
     <p:sldLayoutId id="2147484060" r:id="rId8"/>
-    <p:sldLayoutId id="2147484077" r:id="rId9"/>
+    <p:sldLayoutId id="2147483656" r:id="rId9"/>
+    <p:sldLayoutId id="2147483650" r:id="rId10"/>
+    <p:sldLayoutId id="2147484070" r:id="rId11"/>
+    <p:sldLayoutId id="2147484071" r:id="rId12"/>
   </p:sldLayoutIdLst>
   <p:txStyles>
     <p:titleStyle>
@@ -26718,11 +26872,6 @@
             <a:srgbClr val="F26B43"/>
           </p15:clr>
         </p15:guide>
-        <p15:guide id="6" pos="2880" userDrawn="1">
-          <p15:clr>
-            <a:srgbClr val="F26B43"/>
-          </p15:clr>
-        </p15:guide>
       </p15:sldGuideLst>
     </p:ext>
   </p:extLst>
@@ -26813,78 +26962,6 @@
     <p:extLst>
       <p:ext uri="{BB962C8B-B14F-4D97-AF65-F5344CB8AC3E}">
         <p14:creationId xmlns:p14="http://schemas.microsoft.com/office/powerpoint/2010/main" val="2852840075"/>
-      </p:ext>
-    </p:extLst>
-  </p:cSld>
-  <p:clrMapOvr>
-    <a:masterClrMapping/>
-  </p:clrMapOvr>
-</p:sld>
-</file>
-
-<file path=ppt/slides/slide10.xml><?xml version="1.0" encoding="utf-8"?>
-<p:sld xmlns:a="http://schemas.openxmlformats.org/drawingml/2006/main" xmlns:r="http://schemas.openxmlformats.org/officeDocument/2006/relationships" xmlns:p="http://schemas.openxmlformats.org/presentationml/2006/main">
-  <p:cSld>
-    <p:spTree>
-      <p:nvGrpSpPr>
-        <p:cNvPr id="1" name=""/>
-        <p:cNvGrpSpPr/>
-        <p:nvPr/>
-      </p:nvGrpSpPr>
-      <p:grpSpPr>
-        <a:xfrm>
-          <a:off x="0" y="0"/>
-          <a:ext cx="0" cy="0"/>
-          <a:chOff x="0" y="0"/>
-          <a:chExt cx="0" cy="0"/>
-        </a:xfrm>
-      </p:grpSpPr>
-      <p:sp>
-        <p:nvSpPr>
-          <p:cNvPr id="4" name="Text Placeholder 3">
-            <a:extLst>
-              <a:ext uri="{FF2B5EF4-FFF2-40B4-BE49-F238E27FC236}">
-                <a16:creationId xmlns:a16="http://schemas.microsoft.com/office/drawing/2014/main" id="{9085BD27-5E0B-4AF1-82E4-2FCE3C656DF8}"/>
-              </a:ext>
-            </a:extLst>
-          </p:cNvPr>
-          <p:cNvSpPr>
-            <a:spLocks noGrp="1"/>
-          </p:cNvSpPr>
-          <p:nvPr>
-            <p:ph type="body" sz="quarter" idx="10"/>
-          </p:nvPr>
-        </p:nvSpPr>
-        <p:spPr>
-          <a:xfrm>
-            <a:off x="250825" y="5270691"/>
-            <a:ext cx="8642350" cy="276999"/>
-          </a:xfrm>
-        </p:spPr>
-        <p:txBody>
-          <a:bodyPr/>
-          <a:lstStyle/>
-          <a:p>
-            <a:r>
-              <a:rPr lang="en-GB" dirty="0">
-                <a:hlinkClick r:id="rId2">
-                  <a:extLst>
-                    <a:ext uri="{A12FA001-AC4F-418D-AE19-62706E023703}">
-                      <ahyp:hlinkClr xmlns:ahyp="http://schemas.microsoft.com/office/drawing/2018/hyperlinkcolor" val="tx"/>
-                    </a:ext>
-                  </a:extLst>
-                </a:hlinkClick>
-              </a:rPr>
-              <a:t>collision-help@foresightfactory.co</a:t>
-            </a:r>
-            <a:endParaRPr lang="en-GB" dirty="0"/>
-          </a:p>
-        </p:txBody>
-      </p:sp>
-    </p:spTree>
-    <p:extLst>
-      <p:ext uri="{BB962C8B-B14F-4D97-AF65-F5344CB8AC3E}">
-        <p14:creationId xmlns:p14="http://schemas.microsoft.com/office/powerpoint/2010/main" val="3566619164"/>
       </p:ext>
     </p:extLst>
   </p:cSld>
@@ -27101,182 +27178,6 @@
       </p:grpSpPr>
       <p:sp>
         <p:nvSpPr>
-          <p:cNvPr id="5" name="Text Placeholder 4">
-            <a:extLst>
-              <a:ext uri="{FF2B5EF4-FFF2-40B4-BE49-F238E27FC236}">
-                <a16:creationId xmlns:a16="http://schemas.microsoft.com/office/drawing/2014/main" id="{8058E7F8-A0D7-4821-808E-5C3FFD0C2942}"/>
-              </a:ext>
-            </a:extLst>
-          </p:cNvPr>
-          <p:cNvSpPr>
-            <a:spLocks noGrp="1"/>
-          </p:cNvSpPr>
-          <p:nvPr>
-            <p:ph type="body" sz="quarter" idx="10"/>
-          </p:nvPr>
-        </p:nvSpPr>
-        <p:spPr/>
-        <p:txBody>
-          <a:bodyPr/>
-          <a:lstStyle/>
-          <a:p>
-            <a:endParaRPr lang="en-GB"/>
-          </a:p>
-        </p:txBody>
-      </p:sp>
-      <p:sp>
-        <p:nvSpPr>
-          <p:cNvPr id="4" name="Text Placeholder 3"/>
-          <p:cNvSpPr>
-            <a:spLocks noGrp="1"/>
-          </p:cNvSpPr>
-          <p:nvPr>
-            <p:ph type="body" sz="quarter" idx="11"/>
-          </p:nvPr>
-        </p:nvSpPr>
-        <p:spPr>
-          <a:xfrm>
-            <a:off x="250825" y="1736725"/>
-            <a:ext cx="8642350" cy="4645026"/>
-          </a:xfrm>
-        </p:spPr>
-        <p:txBody>
-          <a:bodyPr/>
-          <a:lstStyle/>
-          <a:p>
-            <a:r>
-              <a:rPr dirty="0" b="1"/>
-              <a:t>Bedtime</a:t>
-            </a:r>
-            <a:r>
-              <a:t>, and </a:t>
-            </a:r>
-            <a:r>
-              <a:rPr dirty="0" i="1"/>
-              <a:t>evening</a:t>
-            </a:r>
-            <a:r>
-              <a:t> time in general, is being re-defined. For a significant number, the hours before sleep can be penetrated by a kind of light work; it is now so easy to curl round a laptop or a tablet and drop your boss an email, while scanning the latest news, while streaming on-demand movies, while online shopping for your mother’s birthday present, and so on. </a:t>
-            </a:r>
-          </a:p>
-          <a:p/>
-          <a:p>
-            <a:r>
-              <a:t> Work-life </a:t>
-            </a:r>
-            <a:r>
-              <a:rPr>
-                <a:hlinkClick r:id="rId100"/>
-              </a:rPr>
-              <a:t>balance</a:t>
-            </a:r>
-            <a:r>
-              <a:t> is redrawn under wider horizons. This is not just a story of more flexible working hours but a story of work encroaching into those times and places formerly reserved for rest: night time, bedrooms, even holidays. To many millennials, work-life balance is in revolution. </a:t>
-            </a:r>
-          </a:p>
-          <a:p>
-            <a:r>
-              <a:t> More, online media and retail are accessed differently in these arenas. Remote technology for both work and socialising means that consumers are engaging with their devices, and their fellow human beings, in a totally new way. </a:t>
-            </a:r>
-          </a:p>
-          <a:p>
-            <a:r>
-              <a:t> Work-life balance is redrawn under wider horizons. This is not just a story of more flexible working hours but a story of work encroaching into those times and places formerly reserved for rest: night time, bedrooms, even holidays. To many millennials, work-life balance is in revolution. </a:t>
-            </a:r>
-          </a:p>
-        </p:txBody>
-      </p:sp>
-      <p:pic>
-        <p:nvPicPr>
-          <p:cNvPr id="1" name="Picture 1" descr="Picture 1"/>
-          <p:cNvPicPr>
-            <a:picLocks noChangeAspect="1" noChangeArrowheads="1"/>
-          </p:cNvPicPr>
-          <p:nvPr/>
-        </p:nvPicPr>
-        <p:blipFill>
-          <a:blip r:embed="rId2" cstate="print"/>
-          <a:srcRect/>
-          <a:stretch>
-            <a:fillRect/>
-          </a:stretch>
-        </p:blipFill>
-        <p:spPr bwMode="auto">
-          <a:xfrm>
-            <a:off x="1016000" y="2451100"/>
-            <a:ext cx="6883400" cy="3644900"/>
-          </a:xfrm>
-          <a:prstGeom prst="rect">
-            <a:avLst/>
-          </a:prstGeom>
-          <a:noFill/>
-        </p:spPr>
-      </p:pic>
-      <p:sp>
-        <p:nvSpPr>
-          <p:cNvPr id="8" name="Title 7">
-            <a:extLst>
-              <a:ext uri="{FF2B5EF4-FFF2-40B4-BE49-F238E27FC236}">
-                <a16:creationId xmlns:a16="http://schemas.microsoft.com/office/drawing/2014/main" id="{F81155E6-8BF1-458B-B680-D4A2EBFAC2B5}"/>
-              </a:ext>
-            </a:extLst>
-          </p:cNvPr>
-          <p:cNvSpPr>
-            <a:spLocks noGrp="1"/>
-          </p:cNvSpPr>
-          <p:nvPr>
-            <p:ph type="title"/>
-          </p:nvPr>
-        </p:nvSpPr>
-        <p:spPr>
-          <a:xfrm>
-            <a:off x="250828" y="727200"/>
-            <a:ext cx="8642348" cy="886397"/>
-          </a:xfrm>
-        </p:spPr>
-        <p:txBody>
-          <a:bodyPr/>
-          <a:lstStyle/>
-          <a:p>
-            <a:r>
-              <a:rPr lang="en-GB" dirty="0"/>
-              <a:t>A very long title to test breaking over two lines works correctly</a:t>
-            </a:r>
-          </a:p>
-        </p:txBody>
-      </p:sp>
-    </p:spTree>
-    <p:extLst>
-      <p:ext uri="{BB962C8B-B14F-4D97-AF65-F5344CB8AC3E}">
-        <p14:creationId xmlns:p14="http://schemas.microsoft.com/office/powerpoint/2010/main" val="3054531529"/>
-      </p:ext>
-    </p:extLst>
-  </p:cSld>
-  <p:clrMapOvr>
-    <a:masterClrMapping/>
-  </p:clrMapOvr>
-</p:sld>
-</file>
-
-<file path=ppt/slides/slide4.xml><?xml version="1.0" encoding="utf-8"?>
-<p:sld xmlns:a="http://schemas.openxmlformats.org/drawingml/2006/main" xmlns:r="http://schemas.openxmlformats.org/officeDocument/2006/relationships" xmlns:p="http://schemas.openxmlformats.org/presentationml/2006/main">
-  <p:cSld>
-    <p:spTree>
-      <p:nvGrpSpPr>
-        <p:cNvPr id="1" name=""/>
-        <p:cNvGrpSpPr/>
-        <p:nvPr/>
-      </p:nvGrpSpPr>
-      <p:grpSpPr>
-        <a:xfrm>
-          <a:off x="0" y="0"/>
-          <a:ext cx="0" cy="0"/>
-          <a:chOff x="0" y="0"/>
-          <a:chExt cx="0" cy="0"/>
-        </a:xfrm>
-      </p:grpSpPr>
-      <p:sp>
-        <p:nvSpPr>
           <p:cNvPr id="2" name="Text Placeholder 1">
             <a:extLst>
               <a:ext uri="{FF2B5EF4-FFF2-40B4-BE49-F238E27FC236}">
@@ -27397,6 +27298,10 @@
               <a:buAutoNum type="arabicPeriod" startAt="4"/>
             </a:pPr>
             <a:r>
+              <a:rPr lang="en-GB" sz="1200" dirty="0"/>
+              <a:t> </a:t>
+            </a:r>
+            <a:r>
               <a:rPr lang="en-GB" sz="1200" b="1" dirty="0">
                 <a:hlinkClick r:id="rId100"/>
               </a:rPr>
@@ -27421,6 +27326,10 @@
               <a:buFont typeface="+mj-lt"/>
               <a:buAutoNum type="arabicPeriod" startAt="4"/>
             </a:pPr>
+            <a:r>
+              <a:rPr lang="en-GB" sz="1200" dirty="0"/>
+              <a:t> </a:t>
+            </a:r>
             <a:r>
               <a:rPr lang="en-GB" sz="1200" b="1" dirty="0">
                 <a:hlinkClick r:id="rId101"/>
@@ -27447,6 +27356,10 @@
               <a:buAutoNum type="arabicPeriod" startAt="4"/>
             </a:pPr>
             <a:r>
+              <a:rPr lang="en-GB" sz="1200" dirty="0"/>
+              <a:t> </a:t>
+            </a:r>
+            <a:r>
               <a:rPr lang="en-GB" sz="1200" b="1" dirty="0">
                 <a:hlinkClick r:id="rId102"/>
               </a:rPr>
@@ -27471,6 +27384,10 @@
               <a:buFont typeface="+mj-lt"/>
               <a:buAutoNum type="arabicPeriod" startAt="4"/>
             </a:pPr>
+            <a:r>
+              <a:rPr lang="en-GB" sz="1200" dirty="0"/>
+              <a:t> </a:t>
+            </a:r>
             <a:r>
               <a:rPr lang="en-GB" sz="1200" b="1" dirty="0">
                 <a:hlinkClick r:id="rId103"/>
@@ -27497,6 +27414,10 @@
               <a:buAutoNum type="arabicPeriod" startAt="4"/>
             </a:pPr>
             <a:r>
+              <a:rPr lang="en-GB" sz="1200" dirty="0"/>
+              <a:t> </a:t>
+            </a:r>
+            <a:r>
               <a:rPr lang="en-GB" sz="1200" b="1" dirty="0">
                 <a:hlinkClick r:id="rId104"/>
               </a:rPr>
@@ -27521,6 +27442,10 @@
               <a:buFont typeface="+mj-lt"/>
               <a:buAutoNum type="arabicPeriod" startAt="4"/>
             </a:pPr>
+            <a:r>
+              <a:rPr lang="en-GB" sz="1200" dirty="0"/>
+              <a:t> </a:t>
+            </a:r>
             <a:r>
               <a:rPr lang="en-GB" sz="1200" b="1" dirty="0">
                 <a:hlinkClick r:id="rId105"/>
@@ -27547,6 +27472,10 @@
               <a:buAutoNum type="arabicPeriod" startAt="4"/>
             </a:pPr>
             <a:r>
+              <a:rPr lang="en-GB" sz="1200" dirty="0"/>
+              <a:t> </a:t>
+            </a:r>
+            <a:r>
               <a:rPr lang="en-GB" sz="1200" b="1" dirty="0">
                 <a:hlinkClick r:id="rId106"/>
               </a:rPr>
@@ -27572,7 +27501,7 @@
       </p:sp>
       <p:sp>
         <p:nvSpPr>
-          <p:cNvPr id="5" name="Text Placeholder 4">
+          <p:cNvPr id="6" name="Text Placeholder 4">
             <a:extLst>
               <a:ext uri="{FF2B5EF4-FFF2-40B4-BE49-F238E27FC236}">
                 <a16:creationId xmlns:a16="http://schemas.microsoft.com/office/drawing/2014/main" id="{5A2A17F5-BDB6-3277-82F6-DE5BCCE429BF}"/>
@@ -27596,6 +27525,10 @@
               <a:buFont typeface="+mj-lt"/>
               <a:buAutoNum type="arabicPeriod" startAt="11"/>
             </a:pPr>
+            <a:r>
+              <a:rPr lang="en-GB" sz="1200" dirty="0"/>
+              <a:t> </a:t>
+            </a:r>
             <a:r>
               <a:rPr lang="en-GB" sz="1200" b="1" dirty="0">
                 <a:hlinkClick r:id="rId100"/>
@@ -27622,6 +27555,10 @@
               <a:buAutoNum type="arabicPeriod" startAt="11"/>
             </a:pPr>
             <a:r>
+              <a:rPr lang="en-GB" sz="1200" dirty="0"/>
+              <a:t> </a:t>
+            </a:r>
+            <a:r>
               <a:rPr lang="en-GB" sz="1200" b="1" dirty="0">
                 <a:hlinkClick r:id="rId101"/>
               </a:rPr>
@@ -27646,6 +27583,10 @@
               <a:buFont typeface="+mj-lt"/>
               <a:buAutoNum type="arabicPeriod" startAt="11"/>
             </a:pPr>
+            <a:r>
+              <a:rPr lang="en-GB" sz="1200" dirty="0"/>
+              <a:t> </a:t>
+            </a:r>
             <a:r>
               <a:rPr lang="en-GB" sz="1200" b="1" dirty="0">
                 <a:hlinkClick r:id="rId102"/>
@@ -27672,6 +27613,10 @@
               <a:buAutoNum type="arabicPeriod" startAt="11"/>
             </a:pPr>
             <a:r>
+              <a:rPr lang="en-GB" sz="1200" dirty="0"/>
+              <a:t> </a:t>
+            </a:r>
+            <a:r>
               <a:rPr lang="en-GB" sz="1200" b="1" dirty="0">
                 <a:hlinkClick r:id="rId103"/>
               </a:rPr>
@@ -27696,6 +27641,10 @@
               <a:buFont typeface="+mj-lt"/>
               <a:buAutoNum type="arabicPeriod" startAt="11"/>
             </a:pPr>
+            <a:r>
+              <a:rPr lang="en-GB" sz="1200" dirty="0"/>
+              <a:t> </a:t>
+            </a:r>
             <a:r>
               <a:rPr lang="en-GB" sz="1200" b="1" dirty="0">
                 <a:hlinkClick r:id="rId104"/>
@@ -27722,6 +27671,10 @@
               <a:buAutoNum type="arabicPeriod" startAt="11"/>
             </a:pPr>
             <a:r>
+              <a:rPr lang="en-GB" sz="1200" dirty="0"/>
+              <a:t> </a:t>
+            </a:r>
+            <a:r>
               <a:rPr lang="en-GB" sz="1200" b="1" dirty="0">
                 <a:hlinkClick r:id="rId105"/>
               </a:rPr>
@@ -27746,6 +27699,10 @@
               <a:buFont typeface="+mj-lt"/>
               <a:buAutoNum type="arabicPeriod" startAt="11"/>
             </a:pPr>
+            <a:r>
+              <a:rPr lang="en-GB" sz="1200" dirty="0"/>
+              <a:t> </a:t>
+            </a:r>
             <a:r>
               <a:rPr lang="en-GB" sz="1200" b="1" dirty="0">
                 <a:hlinkClick r:id="rId106"/>
@@ -27772,7 +27729,7 @@
       </p:sp>
       <p:sp>
         <p:nvSpPr>
-          <p:cNvPr id="5" name="Text Placeholder 4">
+          <p:cNvPr id="7" name="Text Placeholder 4">
             <a:extLst>
               <a:ext uri="{FF2B5EF4-FFF2-40B4-BE49-F238E27FC236}">
                 <a16:creationId xmlns:a16="http://schemas.microsoft.com/office/drawing/2014/main" id="{5A2A17F5-BDB6-3277-82F6-DE5BCCE429BF}"/>
@@ -27796,6 +27753,10 @@
               <a:buFont typeface="+mj-lt"/>
               <a:buAutoNum type="arabicPeriod" startAt="18"/>
             </a:pPr>
+            <a:r>
+              <a:rPr lang="en-GB" sz="1200" dirty="0"/>
+              <a:t> </a:t>
+            </a:r>
             <a:r>
               <a:rPr lang="en-GB" sz="1200" b="1" dirty="0">
                 <a:hlinkClick r:id="rId100"/>
@@ -27822,6 +27783,10 @@
               <a:buAutoNum type="arabicPeriod" startAt="18"/>
             </a:pPr>
             <a:r>
+              <a:rPr lang="en-GB" sz="1200" dirty="0"/>
+              <a:t> </a:t>
+            </a:r>
+            <a:r>
               <a:rPr lang="en-GB" sz="1200" b="1" dirty="0">
                 <a:hlinkClick r:id="rId101"/>
               </a:rPr>
@@ -27846,6 +27811,10 @@
               <a:buFont typeface="+mj-lt"/>
               <a:buAutoNum type="arabicPeriod" startAt="18"/>
             </a:pPr>
+            <a:r>
+              <a:rPr lang="en-GB" sz="1200" dirty="0"/>
+              <a:t> </a:t>
+            </a:r>
             <a:r>
               <a:rPr lang="en-GB" sz="1200" b="1" dirty="0">
                 <a:hlinkClick r:id="rId102"/>
@@ -27872,6 +27841,10 @@
               <a:buAutoNum type="arabicPeriod" startAt="18"/>
             </a:pPr>
             <a:r>
+              <a:rPr lang="en-GB" sz="1200" dirty="0"/>
+              <a:t> </a:t>
+            </a:r>
+            <a:r>
               <a:rPr lang="en-GB" sz="1200" b="1" dirty="0">
                 <a:hlinkClick r:id="rId103"/>
               </a:rPr>
@@ -27896,6 +27869,10 @@
               <a:buFont typeface="+mj-lt"/>
               <a:buAutoNum type="arabicPeriod" startAt="18"/>
             </a:pPr>
+            <a:r>
+              <a:rPr lang="en-GB" sz="1200" dirty="0"/>
+              <a:t> </a:t>
+            </a:r>
             <a:r>
               <a:rPr lang="en-GB" sz="1200" b="1" dirty="0">
                 <a:hlinkClick r:id="rId104"/>
@@ -27922,6 +27899,10 @@
               <a:buAutoNum type="arabicPeriod" startAt="18"/>
             </a:pPr>
             <a:r>
+              <a:rPr lang="en-GB" sz="1200" dirty="0"/>
+              <a:t> </a:t>
+            </a:r>
+            <a:r>
               <a:rPr lang="en-GB" sz="1200" b="1" dirty="0">
                 <a:hlinkClick r:id="rId105"/>
               </a:rPr>
@@ -27946,6 +27927,10 @@
               <a:buFont typeface="+mj-lt"/>
               <a:buAutoNum type="arabicPeriod" startAt="18"/>
             </a:pPr>
+            <a:r>
+              <a:rPr lang="en-GB" sz="1200" dirty="0"/>
+              <a:t> </a:t>
+            </a:r>
             <a:r>
               <a:rPr lang="en-GB" sz="1200" b="1" dirty="0">
                 <a:hlinkClick r:id="rId106"/>
@@ -28088,374 +28073,7 @@
 </p:sld>
 </file>
 
-<file path=ppt/slides/slide5.xml><?xml version="1.0" encoding="utf-8"?>
-<p:sld xmlns:a="http://schemas.openxmlformats.org/drawingml/2006/main" xmlns:r="http://schemas.openxmlformats.org/officeDocument/2006/relationships" xmlns:p="http://schemas.openxmlformats.org/presentationml/2006/main">
-  <p:cSld>
-    <p:spTree>
-      <p:nvGrpSpPr>
-        <p:cNvPr id="1" name=""/>
-        <p:cNvGrpSpPr/>
-        <p:nvPr/>
-      </p:nvGrpSpPr>
-      <p:grpSpPr>
-        <a:xfrm>
-          <a:off x="0" y="0"/>
-          <a:ext cx="0" cy="0"/>
-          <a:chOff x="0" y="0"/>
-          <a:chExt cx="0" cy="0"/>
-        </a:xfrm>
-      </p:grpSpPr>
-      <p:sp>
-        <p:nvSpPr>
-          <p:cNvPr id="5" name="Text Placeholder 4">
-            <a:extLst>
-              <a:ext uri="{FF2B5EF4-FFF2-40B4-BE49-F238E27FC236}">
-                <a16:creationId xmlns:a16="http://schemas.microsoft.com/office/drawing/2014/main" id="{8058E7F8-A0D7-4821-808E-5C3FFD0C2942}"/>
-              </a:ext>
-            </a:extLst>
-          </p:cNvPr>
-          <p:cNvSpPr>
-            <a:spLocks noGrp="1"/>
-          </p:cNvSpPr>
-          <p:nvPr>
-            <p:ph type="body" sz="quarter" idx="10"/>
-          </p:nvPr>
-        </p:nvSpPr>
-        <p:spPr/>
-        <p:txBody>
-          <a:bodyPr/>
-          <a:lstStyle/>
-          <a:p>
-            <a:endParaRPr lang="en-GB"/>
-          </a:p>
-        </p:txBody>
-      </p:sp>
-      <p:sp>
-        <p:nvSpPr>
-          <p:cNvPr id="4" name="Text Placeholder 3"/>
-          <p:cNvSpPr>
-            <a:spLocks noGrp="1"/>
-          </p:cNvSpPr>
-          <p:nvPr>
-            <p:ph type="body" sz="quarter" idx="11"/>
-          </p:nvPr>
-        </p:nvSpPr>
-        <p:spPr>
-          <a:xfrm>
-            <a:off x="250825" y="1736725"/>
-            <a:ext cx="8642350" cy="4645026"/>
-          </a:xfrm>
-        </p:spPr>
-        <p:txBody>
-          <a:bodyPr/>
-          <a:lstStyle/>
-          <a:p>
-            <a:pPr marL="457200" indent="-457200">
-              <a:buFont typeface="Arial" panose="020B0604020202020204" pitchFamily="34" charset="0"/>
-              <a:buChar char="•"/>
-            </a:pPr>
-            <a:r>
-              <a:rPr dirty="0"/>
-              <a:t>Test 1</a:t>
-            </a:r>
-          </a:p>
-          <a:p>
-            <a:pPr marL="457200" indent="-457200">
-              <a:buFont typeface="Arial" panose="020B0604020202020204" pitchFamily="34" charset="0"/>
-              <a:buChar char="•"/>
-            </a:pPr>
-            <a:r>
-              <a:rPr dirty="0"/>
-              <a:t>Test 2</a:t>
-            </a:r>
-          </a:p>
-        </p:txBody>
-      </p:sp>
-      <p:pic>
-        <p:nvPicPr>
-          <p:cNvPr id="1" name="Picture 1" descr="Picture 1"/>
-          <p:cNvPicPr>
-            <a:picLocks noChangeAspect="1" noChangeArrowheads="1"/>
-          </p:cNvPicPr>
-          <p:nvPr/>
-        </p:nvPicPr>
-        <p:blipFill>
-          <a:blip r:embed="rId2" cstate="print"/>
-          <a:srcRect/>
-          <a:stretch>
-            <a:fillRect/>
-          </a:stretch>
-        </p:blipFill>
-        <p:spPr bwMode="auto">
-          <a:xfrm>
-            <a:off x="1016000" y="2451100"/>
-            <a:ext cx="6883400" cy="3644900"/>
-          </a:xfrm>
-          <a:prstGeom prst="rect">
-            <a:avLst/>
-          </a:prstGeom>
-          <a:noFill/>
-        </p:spPr>
-      </p:pic>
-      <p:sp>
-        <p:nvSpPr>
-          <p:cNvPr id="8" name="Title 7">
-            <a:extLst>
-              <a:ext uri="{FF2B5EF4-FFF2-40B4-BE49-F238E27FC236}">
-                <a16:creationId xmlns:a16="http://schemas.microsoft.com/office/drawing/2014/main" id="{F81155E6-8BF1-458B-B680-D4A2EBFAC2B5}"/>
-              </a:ext>
-            </a:extLst>
-          </p:cNvPr>
-          <p:cNvSpPr>
-            <a:spLocks noGrp="1"/>
-          </p:cNvSpPr>
-          <p:nvPr>
-            <p:ph type="title"/>
-          </p:nvPr>
-        </p:nvSpPr>
-        <p:spPr>
-          <a:xfrm>
-            <a:off x="250828" y="727200"/>
-            <a:ext cx="8642348" cy="886397"/>
-          </a:xfrm>
-        </p:spPr>
-        <p:txBody>
-          <a:bodyPr/>
-          <a:lstStyle/>
-          <a:p>
-            <a:r>
-              <a:rPr lang="en-GB" dirty="0"/>
-              <a:t>A very long title to test breaking over two lines works correctly</a:t>
-            </a:r>
-          </a:p>
-        </p:txBody>
-      </p:sp>
-    </p:spTree>
-    <p:extLst>
-      <p:ext uri="{BB962C8B-B14F-4D97-AF65-F5344CB8AC3E}">
-        <p14:creationId xmlns:p14="http://schemas.microsoft.com/office/powerpoint/2010/main" val="3054531529"/>
-      </p:ext>
-    </p:extLst>
-  </p:cSld>
-  <p:clrMapOvr>
-    <a:masterClrMapping/>
-  </p:clrMapOvr>
-</p:sld>
-</file>
-
-<file path=ppt/slides/slide6.xml><?xml version="1.0" encoding="utf-8"?>
-<p:sld xmlns:a="http://schemas.openxmlformats.org/drawingml/2006/main" xmlns:r="http://schemas.openxmlformats.org/officeDocument/2006/relationships" xmlns:p="http://schemas.openxmlformats.org/presentationml/2006/main">
-  <p:cSld>
-    <p:spTree>
-      <p:nvGrpSpPr>
-        <p:cNvPr id="1" name=""/>
-        <p:cNvGrpSpPr/>
-        <p:nvPr/>
-      </p:nvGrpSpPr>
-      <p:grpSpPr>
-        <a:xfrm>
-          <a:off x="0" y="0"/>
-          <a:ext cx="0" cy="0"/>
-          <a:chOff x="0" y="0"/>
-          <a:chExt cx="0" cy="0"/>
-        </a:xfrm>
-      </p:grpSpPr>
-      <p:sp>
-        <p:nvSpPr>
-          <p:cNvPr id="36" name="Text Placeholder 35">
-            <a:extLst>
-              <a:ext uri="{FF2B5EF4-FFF2-40B4-BE49-F238E27FC236}">
-                <a16:creationId xmlns:a16="http://schemas.microsoft.com/office/drawing/2014/main" id="{EDB420C2-915C-4B31-8B9D-AD0E97491AE7}"/>
-              </a:ext>
-            </a:extLst>
-          </p:cNvPr>
-          <p:cNvSpPr>
-            <a:spLocks noGrp="1"/>
-          </p:cNvSpPr>
-          <p:nvPr>
-            <p:ph type="body" sz="quarter" idx="10"/>
-          </p:nvPr>
-        </p:nvSpPr>
-        <p:spPr/>
-        <p:txBody>
-          <a:bodyPr/>
-          <a:lstStyle/>
-          <a:p>
-            <a:endParaRPr lang="en-GB"/>
-          </a:p>
-        </p:txBody>
-      </p:sp>
-      <p:sp>
-        <p:nvSpPr>
-          <p:cNvPr id="3" name="Title 2"/>
-          <p:cNvSpPr>
-            <a:spLocks noGrp="1"/>
-          </p:cNvSpPr>
-          <p:nvPr>
-            <p:ph type="title"/>
-          </p:nvPr>
-        </p:nvSpPr>
-        <p:spPr/>
-        <p:txBody>
-          <a:bodyPr/>
-          <a:lstStyle/>
-          <a:p>
-            <a:r>
-              <a:rPr lang="en-GB" dirty="0"/>
-              <a:t>Lorem Ipsum Dolor Sit Amet</a:t>
-            </a:r>
-          </a:p>
-        </p:txBody>
-      </p:sp>
-      <p:sp>
-        <p:nvSpPr>
-          <p:cNvPr id="4" name="Text Placeholder 3"/>
-          <p:cNvSpPr>
-            <a:spLocks noGrp="1"/>
-          </p:cNvSpPr>
-          <p:nvPr>
-            <p:ph type="body" sz="quarter" idx="11"/>
-          </p:nvPr>
-        </p:nvSpPr>
-        <p:spPr/>
-        <p:txBody>
-          <a:bodyPr/>
-          <a:lstStyle/>
-          <a:p>
-            <a:r>
-              <a:rPr lang="en-GB" dirty="0"/>
-              <a:t>Lorem Ipsum Dolor Consec</a:t>
-            </a:r>
-          </a:p>
-        </p:txBody>
-      </p:sp>
-      <p:sp>
-        <p:nvSpPr>
-          <p:cNvPr id="5" name="Text Placeholder 4"/>
-          <p:cNvSpPr>
-            <a:spLocks noGrp="1"/>
-          </p:cNvSpPr>
-          <p:nvPr>
-            <p:ph type="body" sz="quarter" idx="13"/>
-          </p:nvPr>
-        </p:nvSpPr>
-        <p:spPr/>
-        <p:txBody>
-          <a:bodyPr/>
-          <a:lstStyle/>
-          <a:p>
-            <a:r>
-              <a:rPr lang="en-GB" dirty="0"/>
-              <a:t>Consectetur Adipiscing</a:t>
-            </a:r>
-          </a:p>
-        </p:txBody>
-      </p:sp>
-      <p:sp>
-        <p:nvSpPr>
-          <p:cNvPr id="6" name="Text Placeholder 5"/>
-          <p:cNvSpPr>
-            <a:spLocks noGrp="1"/>
-          </p:cNvSpPr>
-          <p:nvPr>
-            <p:ph type="body" sz="quarter" idx="15"/>
-          </p:nvPr>
-        </p:nvSpPr>
-        <p:spPr/>
-        <p:txBody>
-          <a:bodyPr/>
-          <a:lstStyle/>
-          <a:p>
-            <a:r>
-              <a:rPr lang="en-GB" dirty="0"/>
-              <a:t>Pariatur Consectetur</a:t>
-            </a:r>
-          </a:p>
-        </p:txBody>
-      </p:sp>
-      <p:sp>
-        <p:nvSpPr>
-          <p:cNvPr id="7" name="Text Placeholder 6"/>
-          <p:cNvSpPr>
-            <a:spLocks noGrp="1"/>
-          </p:cNvSpPr>
-          <p:nvPr>
-            <p:ph type="body" sz="quarter" idx="17"/>
-          </p:nvPr>
-        </p:nvSpPr>
-        <p:spPr/>
-        <p:txBody>
-          <a:bodyPr/>
-          <a:lstStyle/>
-          <a:p>
-            <a:r>
-              <a:t> Testing </a:t>
-            </a:r>
-            <a:r>
-              <a:rPr>
-                <a:hlinkClick r:id="rId100"/>
-              </a:rPr>
-              <a:t>blah blah</a:t>
-            </a:r>
-          </a:p>
-        </p:txBody>
-      </p:sp>
-      <p:sp>
-        <p:nvSpPr>
-          <p:cNvPr id="8" name="Text Placeholder 7"/>
-          <p:cNvSpPr>
-            <a:spLocks noGrp="1"/>
-          </p:cNvSpPr>
-          <p:nvPr>
-            <p:ph type="body" sz="quarter" idx="18"/>
-          </p:nvPr>
-        </p:nvSpPr>
-        <p:spPr/>
-        <p:txBody>
-          <a:bodyPr/>
-          <a:lstStyle/>
-          <a:p>
-            <a:r>
-              <a:t> test </a:t>
-            </a:r>
-          </a:p>
-        </p:txBody>
-      </p:sp>
-      <p:sp>
-        <p:nvSpPr>
-          <p:cNvPr id="9" name="Text Placeholder 8"/>
-          <p:cNvSpPr>
-            <a:spLocks noGrp="1"/>
-          </p:cNvSpPr>
-          <p:nvPr>
-            <p:ph type="body" sz="quarter" idx="19"/>
-          </p:nvPr>
-        </p:nvSpPr>
-        <p:spPr/>
-        <p:txBody>
-          <a:bodyPr/>
-          <a:lstStyle/>
-          <a:p>
-            <a:r>
-              <a:t> test </a:t>
-            </a:r>
-          </a:p>
-        </p:txBody>
-      </p:sp>
-    </p:spTree>
-    <p:extLst>
-      <p:ext uri="{BB962C8B-B14F-4D97-AF65-F5344CB8AC3E}">
-        <p14:creationId xmlns:p14="http://schemas.microsoft.com/office/powerpoint/2010/main" val="4051874585"/>
-      </p:ext>
-    </p:extLst>
-  </p:cSld>
-  <p:clrMapOvr>
-    <a:masterClrMapping/>
-  </p:clrMapOvr>
-</p:sld>
-</file>
-
-<file path=ppt/slides/slide7.xml><?xml version="1.0" encoding="utf-8"?>
+<file path=ppt/slides/slide4.xml><?xml version="1.0" encoding="utf-8"?>
 <p:sld xmlns:a="http://schemas.openxmlformats.org/drawingml/2006/main" xmlns:r="http://schemas.openxmlformats.org/officeDocument/2006/relationships" xmlns:p="http://schemas.openxmlformats.org/presentationml/2006/main">
   <p:cSld>
     <p:spTree>
@@ -28814,7 +28432,7 @@
 </p:sld>
 </file>
 
-<file path=ppt/slides/slide8.xml><?xml version="1.0" encoding="utf-8"?>
+<file path=ppt/slides/slide5.xml><?xml version="1.0" encoding="utf-8"?>
 <p:sld xmlns:a="http://schemas.openxmlformats.org/drawingml/2006/main" xmlns:r="http://schemas.openxmlformats.org/officeDocument/2006/relationships" xmlns:p="http://schemas.openxmlformats.org/presentationml/2006/main">
   <p:cSld>
     <p:spTree>
@@ -29173,7 +28791,7 @@
 </p:sld>
 </file>
 
-<file path=ppt/slides/slide9.xml><?xml version="1.0" encoding="utf-8"?>
+<file path=ppt/slides/slide6.xml><?xml version="1.0" encoding="utf-8"?>
 <p:sld xmlns:a="http://schemas.openxmlformats.org/drawingml/2006/main" xmlns:r="http://schemas.openxmlformats.org/officeDocument/2006/relationships" xmlns:p="http://schemas.openxmlformats.org/presentationml/2006/main">
   <p:cSld>
     <p:spTree>
@@ -29282,6 +28900,171 @@
     <a:masterClrMapping/>
   </p:clrMapOvr>
   <p:transition/>
+</p:sld>
+</file>
+
+<file path=ppt/slides/slide7.xml><?xml version="1.0" encoding="utf-8"?>
+<p:sld xmlns:a="http://schemas.openxmlformats.org/drawingml/2006/main" xmlns:r="http://schemas.openxmlformats.org/officeDocument/2006/relationships" xmlns:p="http://schemas.openxmlformats.org/presentationml/2006/main">
+  <p:cSld>
+    <p:bg>
+      <p:bgPr>
+        <a:blipFill dpi="0" rotWithShape="1">
+          <a:blip r:embed="rId2" cstate="email">
+            <a:lum/>
+            <a:extLst>
+              <a:ext uri="{28A0092B-C50C-407E-A947-70E740481C1C}">
+                <a14:useLocalDpi xmlns:a14="http://schemas.microsoft.com/office/drawing/2010/main"/>
+              </a:ext>
+            </a:extLst>
+          </a:blip>
+          <a:srcRect/>
+          <a:stretch>
+            <a:fillRect/>
+          </a:stretch>
+        </a:blipFill>
+        <a:effectLst/>
+      </p:bgPr>
+    </p:bg>
+    <p:spTree>
+      <p:nvGrpSpPr>
+        <p:cNvPr id="1" name=""/>
+        <p:cNvGrpSpPr/>
+        <p:nvPr/>
+      </p:nvGrpSpPr>
+      <p:grpSpPr>
+        <a:xfrm>
+          <a:off x="0" y="0"/>
+          <a:ext cx="0" cy="0"/>
+          <a:chOff x="0" y="0"/>
+          <a:chExt cx="0" cy="0"/>
+        </a:xfrm>
+      </p:grpSpPr>
+      <p:sp>
+        <p:nvSpPr>
+          <p:cNvPr id="3" name="Text Placeholder 2"/>
+          <p:cNvSpPr>
+            <a:spLocks noGrp="1"/>
+          </p:cNvSpPr>
+          <p:nvPr>
+            <p:ph type="body" sz="quarter" idx="11"/>
+          </p:nvPr>
+        </p:nvSpPr>
+        <p:spPr/>
+        <p:txBody>
+          <a:bodyPr/>
+          <a:lstStyle/>
+          <a:p>
+            <a:r>
+              <a:rPr lang="en-GB" dirty="0"/>
+              <a:t>Test Associated Content Subtitle</a:t>
+            </a:r>
+          </a:p>
+        </p:txBody>
+      </p:sp>
+      <p:sp>
+        <p:nvSpPr>
+          <p:cNvPr id="2" name="Text Placeholder 1"/>
+          <p:cNvSpPr>
+            <a:spLocks noGrp="1"/>
+          </p:cNvSpPr>
+          <p:nvPr>
+            <p:ph type="body" sz="quarter" idx="10"/>
+          </p:nvPr>
+        </p:nvSpPr>
+        <p:spPr/>
+        <p:txBody>
+          <a:bodyPr/>
+          <a:lstStyle/>
+          <a:p>
+            <a:r>
+              <a:rPr lang="en-GB" dirty="0"/>
+              <a:t>Sample Asscociated Content...</a:t>
+            </a:r>
+          </a:p>
+        </p:txBody>
+      </p:sp>
+    </p:spTree>
+    <p:extLst>
+      <p:ext uri="{BB962C8B-B14F-4D97-AF65-F5344CB8AC3E}">
+        <p14:creationId xmlns:p14="http://schemas.microsoft.com/office/powerpoint/2010/main" val="2852840075"/>
+      </p:ext>
+    </p:extLst>
+  </p:cSld>
+  <p:clrMapOvr>
+    <a:masterClrMapping/>
+  </p:clrMapOvr>
+</p:sld>
+</file>
+
+<file path=ppt/slides/slide8.xml><?xml version="1.0" encoding="utf-8"?>
+<p:sld xmlns:a="http://schemas.openxmlformats.org/drawingml/2006/main" xmlns:r="http://schemas.openxmlformats.org/officeDocument/2006/relationships" xmlns:p="http://schemas.openxmlformats.org/presentationml/2006/main">
+  <p:cSld>
+    <p:spTree>
+      <p:nvGrpSpPr>
+        <p:cNvPr id="1" name=""/>
+        <p:cNvGrpSpPr/>
+        <p:nvPr/>
+      </p:nvGrpSpPr>
+      <p:grpSpPr>
+        <a:xfrm>
+          <a:off x="0" y="0"/>
+          <a:ext cx="0" cy="0"/>
+          <a:chOff x="0" y="0"/>
+          <a:chExt cx="0" cy="0"/>
+        </a:xfrm>
+      </p:grpSpPr>
+      <p:sp>
+        <p:nvSpPr>
+          <p:cNvPr id="4" name="Text Placeholder 3">
+            <a:extLst>
+              <a:ext uri="{FF2B5EF4-FFF2-40B4-BE49-F238E27FC236}">
+                <a16:creationId xmlns:a16="http://schemas.microsoft.com/office/drawing/2014/main" id="{9085BD27-5E0B-4AF1-82E4-2FCE3C656DF8}"/>
+              </a:ext>
+            </a:extLst>
+          </p:cNvPr>
+          <p:cNvSpPr>
+            <a:spLocks noGrp="1"/>
+          </p:cNvSpPr>
+          <p:nvPr>
+            <p:ph type="body" sz="quarter" idx="10"/>
+          </p:nvPr>
+        </p:nvSpPr>
+        <p:spPr>
+          <a:xfrm>
+            <a:off x="250825" y="5270691"/>
+            <a:ext cx="8642350" cy="276999"/>
+          </a:xfrm>
+        </p:spPr>
+        <p:txBody>
+          <a:bodyPr/>
+          <a:lstStyle/>
+          <a:p>
+            <a:r>
+              <a:rPr lang="en-GB" dirty="0">
+                <a:hlinkClick r:id="rId2">
+                  <a:extLst>
+                    <a:ext uri="{A12FA001-AC4F-418D-AE19-62706E023703}">
+                      <ahyp:hlinkClr xmlns:ahyp="http://schemas.microsoft.com/office/drawing/2018/hyperlinkcolor" val="tx"/>
+                    </a:ext>
+                  </a:extLst>
+                </a:hlinkClick>
+              </a:rPr>
+              <a:t>collision-help@foresightfactory.co</a:t>
+            </a:r>
+            <a:endParaRPr lang="en-GB" dirty="0"/>
+          </a:p>
+        </p:txBody>
+      </p:sp>
+    </p:spTree>
+    <p:extLst>
+      <p:ext uri="{BB962C8B-B14F-4D97-AF65-F5344CB8AC3E}">
+        <p14:creationId xmlns:p14="http://schemas.microsoft.com/office/powerpoint/2010/main" val="3566619164"/>
+      </p:ext>
+    </p:extLst>
+  </p:cSld>
+  <p:clrMapOvr>
+    <a:masterClrMapping/>
+  </p:clrMapOvr>
 </p:sld>
 </file>
 

</xml_diff>